<commit_message>
skin 3 method diagram pptx change
</commit_message>
<xml_diff>
--- a/Skin Cancer-Segmentation and Classification/Methodology Diagram.pptx
+++ b/Skin Cancer-Segmentation and Classification/Methodology Diagram.pptx
@@ -5,7 +5,7 @@
     <p:sldMasterId id="2147483660" r:id="rId1"/>
   </p:sldMasterIdLst>
   <p:notesMasterIdLst>
-    <p:notesMasterId r:id="rId7"/>
+    <p:notesMasterId r:id="rId8"/>
   </p:notesMasterIdLst>
   <p:sldIdLst>
     <p:sldId id="257" r:id="rId2"/>
@@ -13,6 +13,7 @@
     <p:sldId id="259" r:id="rId4"/>
     <p:sldId id="260" r:id="rId5"/>
     <p:sldId id="261" r:id="rId6"/>
+    <p:sldId id="262" r:id="rId7"/>
   </p:sldIdLst>
   <p:sldSz cx="22860000" cy="22860000"/>
   <p:notesSz cx="6858000" cy="9144000"/>
@@ -201,7 +202,7 @@
           <a:p>
             <a:fld id="{378A0670-F17F-4623-92BF-9C144C9C1535}" type="datetimeFigureOut">
               <a:rPr lang="en-US" smtClean="0"/>
-              <a:t>09-Sep-25</a:t>
+              <a:t>17-Oct-25</a:t>
             </a:fld>
             <a:endParaRPr lang="en-US"/>
           </a:p>
@@ -599,7 +600,7 @@
           <a:p>
             <a:fld id="{7D899EA1-C3E9-4374-BA4D-3DAC1C3DB20C}" type="datetimeFigureOut">
               <a:rPr lang="en-US" smtClean="0"/>
-              <a:t>09-Sep-25</a:t>
+              <a:t>17-Oct-25</a:t>
             </a:fld>
             <a:endParaRPr lang="en-US"/>
           </a:p>
@@ -769,7 +770,7 @@
           <a:p>
             <a:fld id="{7D899EA1-C3E9-4374-BA4D-3DAC1C3DB20C}" type="datetimeFigureOut">
               <a:rPr lang="en-US" smtClean="0"/>
-              <a:t>09-Sep-25</a:t>
+              <a:t>17-Oct-25</a:t>
             </a:fld>
             <a:endParaRPr lang="en-US"/>
           </a:p>
@@ -949,7 +950,7 @@
           <a:p>
             <a:fld id="{7D899EA1-C3E9-4374-BA4D-3DAC1C3DB20C}" type="datetimeFigureOut">
               <a:rPr lang="en-US" smtClean="0"/>
-              <a:t>09-Sep-25</a:t>
+              <a:t>17-Oct-25</a:t>
             </a:fld>
             <a:endParaRPr lang="en-US"/>
           </a:p>
@@ -1119,7 +1120,7 @@
           <a:p>
             <a:fld id="{7D899EA1-C3E9-4374-BA4D-3DAC1C3DB20C}" type="datetimeFigureOut">
               <a:rPr lang="en-US" smtClean="0"/>
-              <a:t>09-Sep-25</a:t>
+              <a:t>17-Oct-25</a:t>
             </a:fld>
             <a:endParaRPr lang="en-US"/>
           </a:p>
@@ -1365,7 +1366,7 @@
           <a:p>
             <a:fld id="{7D899EA1-C3E9-4374-BA4D-3DAC1C3DB20C}" type="datetimeFigureOut">
               <a:rPr lang="en-US" smtClean="0"/>
-              <a:t>09-Sep-25</a:t>
+              <a:t>17-Oct-25</a:t>
             </a:fld>
             <a:endParaRPr lang="en-US"/>
           </a:p>
@@ -1597,7 +1598,7 @@
           <a:p>
             <a:fld id="{7D899EA1-C3E9-4374-BA4D-3DAC1C3DB20C}" type="datetimeFigureOut">
               <a:rPr lang="en-US" smtClean="0"/>
-              <a:t>09-Sep-25</a:t>
+              <a:t>17-Oct-25</a:t>
             </a:fld>
             <a:endParaRPr lang="en-US"/>
           </a:p>
@@ -1964,7 +1965,7 @@
           <a:p>
             <a:fld id="{7D899EA1-C3E9-4374-BA4D-3DAC1C3DB20C}" type="datetimeFigureOut">
               <a:rPr lang="en-US" smtClean="0"/>
-              <a:t>09-Sep-25</a:t>
+              <a:t>17-Oct-25</a:t>
             </a:fld>
             <a:endParaRPr lang="en-US"/>
           </a:p>
@@ -2082,7 +2083,7 @@
           <a:p>
             <a:fld id="{7D899EA1-C3E9-4374-BA4D-3DAC1C3DB20C}" type="datetimeFigureOut">
               <a:rPr lang="en-US" smtClean="0"/>
-              <a:t>09-Sep-25</a:t>
+              <a:t>17-Oct-25</a:t>
             </a:fld>
             <a:endParaRPr lang="en-US"/>
           </a:p>
@@ -2177,7 +2178,7 @@
           <a:p>
             <a:fld id="{7D899EA1-C3E9-4374-BA4D-3DAC1C3DB20C}" type="datetimeFigureOut">
               <a:rPr lang="en-US" smtClean="0"/>
-              <a:t>09-Sep-25</a:t>
+              <a:t>17-Oct-25</a:t>
             </a:fld>
             <a:endParaRPr lang="en-US"/>
           </a:p>
@@ -2454,7 +2455,7 @@
           <a:p>
             <a:fld id="{7D899EA1-C3E9-4374-BA4D-3DAC1C3DB20C}" type="datetimeFigureOut">
               <a:rPr lang="en-US" smtClean="0"/>
-              <a:t>09-Sep-25</a:t>
+              <a:t>17-Oct-25</a:t>
             </a:fld>
             <a:endParaRPr lang="en-US"/>
           </a:p>
@@ -2711,7 +2712,7 @@
           <a:p>
             <a:fld id="{7D899EA1-C3E9-4374-BA4D-3DAC1C3DB20C}" type="datetimeFigureOut">
               <a:rPr lang="en-US" smtClean="0"/>
-              <a:t>09-Sep-25</a:t>
+              <a:t>17-Oct-25</a:t>
             </a:fld>
             <a:endParaRPr lang="en-US"/>
           </a:p>
@@ -2924,7 +2925,7 @@
           <a:p>
             <a:fld id="{7D899EA1-C3E9-4374-BA4D-3DAC1C3DB20C}" type="datetimeFigureOut">
               <a:rPr lang="en-US" smtClean="0"/>
-              <a:t>09-Sep-25</a:t>
+              <a:t>17-Oct-25</a:t>
             </a:fld>
             <a:endParaRPr lang="en-US"/>
           </a:p>
@@ -32628,6 +32629,3145 @@
 </p:sld>
 </file>
 
+<file path=ppt/slides/slide6.xml><?xml version="1.0" encoding="utf-8"?>
+<p:sld xmlns:a="http://schemas.openxmlformats.org/drawingml/2006/main" xmlns:r="http://schemas.openxmlformats.org/officeDocument/2006/relationships" xmlns:p="http://schemas.openxmlformats.org/presentationml/2006/main">
+  <p:cSld>
+    <p:spTree>
+      <p:nvGrpSpPr>
+        <p:cNvPr id="1" name="">
+          <a:extLst>
+            <a:ext uri="{FF2B5EF4-FFF2-40B4-BE49-F238E27FC236}">
+              <a16:creationId xmlns:a16="http://schemas.microsoft.com/office/drawing/2014/main" id="{3112640C-9279-F76B-8DA3-68D0D6A801C4}"/>
+            </a:ext>
+          </a:extLst>
+        </p:cNvPr>
+        <p:cNvGrpSpPr/>
+        <p:nvPr/>
+      </p:nvGrpSpPr>
+      <p:grpSpPr>
+        <a:xfrm>
+          <a:off x="0" y="0"/>
+          <a:ext cx="0" cy="0"/>
+          <a:chOff x="0" y="0"/>
+          <a:chExt cx="0" cy="0"/>
+        </a:xfrm>
+      </p:grpSpPr>
+      <p:grpSp>
+        <p:nvGrpSpPr>
+          <p:cNvPr id="3" name="Group 2">
+            <a:extLst>
+              <a:ext uri="{FF2B5EF4-FFF2-40B4-BE49-F238E27FC236}">
+                <a16:creationId xmlns:a16="http://schemas.microsoft.com/office/drawing/2014/main" id="{4BF759BA-4DFD-F79E-C663-4A00E28879A0}"/>
+              </a:ext>
+            </a:extLst>
+          </p:cNvPr>
+          <p:cNvGrpSpPr/>
+          <p:nvPr/>
+        </p:nvGrpSpPr>
+        <p:grpSpPr>
+          <a:xfrm>
+            <a:off x="1685706" y="4400991"/>
+            <a:ext cx="12139898" cy="7574169"/>
+            <a:chOff x="1685706" y="4400991"/>
+            <a:chExt cx="12139898" cy="7574169"/>
+          </a:xfrm>
+        </p:grpSpPr>
+        <p:sp>
+          <p:nvSpPr>
+            <p:cNvPr id="1071" name="Rectangle: Rounded Corners 1070">
+              <a:extLst>
+                <a:ext uri="{FF2B5EF4-FFF2-40B4-BE49-F238E27FC236}">
+                  <a16:creationId xmlns:a16="http://schemas.microsoft.com/office/drawing/2014/main" id="{196DF71D-7033-94D2-E105-EA23E6A7DCBC}"/>
+                </a:ext>
+              </a:extLst>
+            </p:cNvPr>
+            <p:cNvSpPr/>
+            <p:nvPr/>
+          </p:nvSpPr>
+          <p:spPr>
+            <a:xfrm>
+              <a:off x="3714750" y="4704113"/>
+              <a:ext cx="7428407" cy="2254378"/>
+            </a:xfrm>
+            <a:prstGeom prst="roundRect">
+              <a:avLst/>
+            </a:prstGeom>
+            <a:solidFill>
+              <a:srgbClr val="E8EEF2"/>
+            </a:solidFill>
+            <a:ln>
+              <a:solidFill>
+                <a:srgbClr val="D8BEEC"/>
+              </a:solidFill>
+            </a:ln>
+          </p:spPr>
+          <p:style>
+            <a:lnRef idx="2">
+              <a:schemeClr val="accent1">
+                <a:shade val="15000"/>
+              </a:schemeClr>
+            </a:lnRef>
+            <a:fillRef idx="1">
+              <a:schemeClr val="accent1"/>
+            </a:fillRef>
+            <a:effectRef idx="0">
+              <a:schemeClr val="accent1"/>
+            </a:effectRef>
+            <a:fontRef idx="minor">
+              <a:schemeClr val="lt1"/>
+            </a:fontRef>
+          </p:style>
+          <p:txBody>
+            <a:bodyPr rtlCol="0" anchor="ctr"/>
+            <a:lstStyle/>
+            <a:p>
+              <a:pPr algn="ctr"/>
+              <a:endParaRPr lang="en-US"/>
+            </a:p>
+          </p:txBody>
+        </p:sp>
+        <p:pic>
+          <p:nvPicPr>
+            <p:cNvPr id="1026" name="Picture 2">
+              <a:extLst>
+                <a:ext uri="{FF2B5EF4-FFF2-40B4-BE49-F238E27FC236}">
+                  <a16:creationId xmlns:a16="http://schemas.microsoft.com/office/drawing/2014/main" id="{FF3B24DC-EAFC-7DA3-8DF7-593FE2CF8A27}"/>
+                </a:ext>
+              </a:extLst>
+            </p:cNvPr>
+            <p:cNvPicPr>
+              <a:picLocks noChangeAspect="1" noChangeArrowheads="1"/>
+            </p:cNvPicPr>
+            <p:nvPr/>
+          </p:nvPicPr>
+          <p:blipFill rotWithShape="1">
+            <a:blip r:embed="rId2">
+              <a:extLst>
+                <a:ext uri="{28A0092B-C50C-407E-A947-70E740481C1C}">
+                  <a14:useLocalDpi xmlns:a14="http://schemas.microsoft.com/office/drawing/2010/main" val="0"/>
+                </a:ext>
+              </a:extLst>
+            </a:blip>
+            <a:srcRect l="11001" r="27665" b="16667"/>
+            <a:stretch>
+              <a:fillRect/>
+            </a:stretch>
+          </p:blipFill>
+          <p:spPr bwMode="auto">
+            <a:xfrm>
+              <a:off x="1685706" y="6146130"/>
+              <a:ext cx="1838543" cy="1873515"/>
+            </a:xfrm>
+            <a:prstGeom prst="rect">
+              <a:avLst/>
+            </a:prstGeom>
+            <a:noFill/>
+            <a:extLst>
+              <a:ext uri="{909E8E84-426E-40DD-AFC4-6F175D3DCCD1}">
+                <a14:hiddenFill xmlns:a14="http://schemas.microsoft.com/office/drawing/2010/main">
+                  <a:solidFill>
+                    <a:srgbClr val="FFFFFF"/>
+                  </a:solidFill>
+                </a14:hiddenFill>
+              </a:ext>
+            </a:extLst>
+          </p:spPr>
+        </p:pic>
+        <p:sp>
+          <p:nvSpPr>
+            <p:cNvPr id="1027" name="TextBox 1026">
+              <a:extLst>
+                <a:ext uri="{FF2B5EF4-FFF2-40B4-BE49-F238E27FC236}">
+                  <a16:creationId xmlns:a16="http://schemas.microsoft.com/office/drawing/2014/main" id="{EB33B5EA-CC00-7C87-979D-42268FABB312}"/>
+                </a:ext>
+              </a:extLst>
+            </p:cNvPr>
+            <p:cNvSpPr txBox="1"/>
+            <p:nvPr/>
+          </p:nvSpPr>
+          <p:spPr>
+            <a:xfrm>
+              <a:off x="2075825" y="5846032"/>
+              <a:ext cx="1058303" cy="338554"/>
+            </a:xfrm>
+            <a:prstGeom prst="rect">
+              <a:avLst/>
+            </a:prstGeom>
+            <a:noFill/>
+          </p:spPr>
+          <p:txBody>
+            <a:bodyPr wrap="none" rtlCol="0">
+              <a:spAutoFit/>
+            </a:bodyPr>
+            <a:lstStyle/>
+            <a:p>
+              <a:r>
+                <a:rPr lang="en-US" sz="1600" dirty="0">
+                  <a:latin typeface="Times New Roman" panose="02020603050405020304" pitchFamily="18" charset="0"/>
+                  <a:cs typeface="Times New Roman" panose="02020603050405020304" pitchFamily="18" charset="0"/>
+                </a:rPr>
+                <a:t>Input Data</a:t>
+              </a:r>
+            </a:p>
+          </p:txBody>
+        </p:sp>
+        <p:sp>
+          <p:nvSpPr>
+            <p:cNvPr id="1050" name="Rectangle: Rounded Corners 1049">
+              <a:extLst>
+                <a:ext uri="{FF2B5EF4-FFF2-40B4-BE49-F238E27FC236}">
+                  <a16:creationId xmlns:a16="http://schemas.microsoft.com/office/drawing/2014/main" id="{7BD398C8-88E5-06B9-D662-B40F5A27A200}"/>
+                </a:ext>
+              </a:extLst>
+            </p:cNvPr>
+            <p:cNvSpPr/>
+            <p:nvPr/>
+          </p:nvSpPr>
+          <p:spPr>
+            <a:xfrm>
+              <a:off x="3851722" y="4962526"/>
+              <a:ext cx="1788861" cy="1821554"/>
+            </a:xfrm>
+            <a:prstGeom prst="roundRect">
+              <a:avLst/>
+            </a:prstGeom>
+            <a:noFill/>
+            <a:ln>
+              <a:solidFill>
+                <a:schemeClr val="tx1"/>
+              </a:solidFill>
+              <a:prstDash val="dashDot"/>
+            </a:ln>
+          </p:spPr>
+          <p:style>
+            <a:lnRef idx="2">
+              <a:schemeClr val="accent6"/>
+            </a:lnRef>
+            <a:fillRef idx="1">
+              <a:schemeClr val="lt1"/>
+            </a:fillRef>
+            <a:effectRef idx="0">
+              <a:schemeClr val="accent6"/>
+            </a:effectRef>
+            <a:fontRef idx="minor">
+              <a:schemeClr val="dk1"/>
+            </a:fontRef>
+          </p:style>
+          <p:txBody>
+            <a:bodyPr rtlCol="0" anchor="ctr"/>
+            <a:lstStyle/>
+            <a:p>
+              <a:pPr algn="ctr"/>
+              <a:endParaRPr lang="en-US"/>
+            </a:p>
+          </p:txBody>
+        </p:sp>
+        <p:sp>
+          <p:nvSpPr>
+            <p:cNvPr id="1052" name="TextBox 1051">
+              <a:extLst>
+                <a:ext uri="{FF2B5EF4-FFF2-40B4-BE49-F238E27FC236}">
+                  <a16:creationId xmlns:a16="http://schemas.microsoft.com/office/drawing/2014/main" id="{E0E620CE-26BD-E225-C675-C13765078843}"/>
+                </a:ext>
+              </a:extLst>
+            </p:cNvPr>
+            <p:cNvSpPr txBox="1"/>
+            <p:nvPr/>
+          </p:nvSpPr>
+          <p:spPr>
+            <a:xfrm>
+              <a:off x="4336848" y="4704113"/>
+              <a:ext cx="818605" cy="305422"/>
+            </a:xfrm>
+            <a:prstGeom prst="rect">
+              <a:avLst/>
+            </a:prstGeom>
+            <a:noFill/>
+            <a:ln>
+              <a:noFill/>
+            </a:ln>
+            <a:effectLst/>
+            <a:scene3d>
+              <a:camera prst="orthographicFront">
+                <a:rot lat="0" lon="0" rev="0"/>
+              </a:camera>
+              <a:lightRig rig="contrasting" dir="t">
+                <a:rot lat="0" lon="0" rev="7800000"/>
+              </a:lightRig>
+            </a:scene3d>
+            <a:sp3d>
+              <a:bevelT w="139700" h="139700"/>
+            </a:sp3d>
+          </p:spPr>
+          <p:txBody>
+            <a:bodyPr wrap="square" rtlCol="0">
+              <a:spAutoFit/>
+            </a:bodyPr>
+            <a:lstStyle/>
+            <a:p>
+              <a:pPr algn="ctr"/>
+              <a:r>
+                <a:rPr lang="en-US" sz="1400" dirty="0">
+                  <a:latin typeface="Times New Roman" panose="02020603050405020304" pitchFamily="18" charset="0"/>
+                  <a:cs typeface="Times New Roman" panose="02020603050405020304" pitchFamily="18" charset="0"/>
+                </a:rPr>
+                <a:t>Stage 1</a:t>
+              </a:r>
+            </a:p>
+          </p:txBody>
+        </p:sp>
+        <p:sp>
+          <p:nvSpPr>
+            <p:cNvPr id="1053" name="TextBox 1052">
+              <a:extLst>
+                <a:ext uri="{FF2B5EF4-FFF2-40B4-BE49-F238E27FC236}">
+                  <a16:creationId xmlns:a16="http://schemas.microsoft.com/office/drawing/2014/main" id="{40BC44EF-1D78-4E75-0433-A1B5B73CE3BE}"/>
+                </a:ext>
+              </a:extLst>
+            </p:cNvPr>
+            <p:cNvSpPr txBox="1"/>
+            <p:nvPr/>
+          </p:nvSpPr>
+          <p:spPr>
+            <a:xfrm>
+              <a:off x="4119031" y="5135552"/>
+              <a:ext cx="1210589" cy="1569660"/>
+            </a:xfrm>
+            <a:prstGeom prst="rect">
+              <a:avLst/>
+            </a:prstGeom>
+            <a:noFill/>
+          </p:spPr>
+          <p:txBody>
+            <a:bodyPr wrap="none" rtlCol="0">
+              <a:spAutoFit/>
+            </a:bodyPr>
+            <a:lstStyle/>
+            <a:p>
+              <a:pPr algn="ctr"/>
+              <a:r>
+                <a:rPr lang="en-US" sz="1600" dirty="0">
+                  <a:latin typeface="Times New Roman" panose="02020603050405020304" pitchFamily="18" charset="0"/>
+                  <a:cs typeface="Times New Roman" panose="02020603050405020304" pitchFamily="18" charset="0"/>
+                </a:rPr>
+                <a:t>Pretrained </a:t>
+              </a:r>
+            </a:p>
+            <a:p>
+              <a:pPr algn="ctr"/>
+              <a:r>
+                <a:rPr lang="en-US" sz="1600" dirty="0" err="1">
+                  <a:latin typeface="Times New Roman" panose="02020603050405020304" pitchFamily="18" charset="0"/>
+                  <a:cs typeface="Times New Roman" panose="02020603050405020304" pitchFamily="18" charset="0"/>
+                </a:rPr>
+                <a:t>Xception</a:t>
+              </a:r>
+              <a:r>
+                <a:rPr lang="en-US" sz="1600" dirty="0">
+                  <a:latin typeface="Times New Roman" panose="02020603050405020304" pitchFamily="18" charset="0"/>
+                  <a:cs typeface="Times New Roman" panose="02020603050405020304" pitchFamily="18" charset="0"/>
+                </a:rPr>
+                <a:t> </a:t>
+              </a:r>
+            </a:p>
+            <a:p>
+              <a:pPr algn="ctr"/>
+              <a:r>
+                <a:rPr lang="en-US" sz="1600" dirty="0">
+                  <a:latin typeface="Times New Roman" panose="02020603050405020304" pitchFamily="18" charset="0"/>
+                  <a:cs typeface="Times New Roman" panose="02020603050405020304" pitchFamily="18" charset="0"/>
+                </a:rPr>
+                <a:t>CNN Model</a:t>
+              </a:r>
+            </a:p>
+            <a:p>
+              <a:pPr algn="ctr"/>
+              <a:r>
+                <a:rPr lang="en-US" sz="1600" dirty="0">
+                  <a:latin typeface="Times New Roman" panose="02020603050405020304" pitchFamily="18" charset="0"/>
+                  <a:cs typeface="Times New Roman" panose="02020603050405020304" pitchFamily="18" charset="0"/>
+                </a:rPr>
+                <a:t>Fine Tuned</a:t>
+              </a:r>
+            </a:p>
+            <a:p>
+              <a:pPr algn="ctr"/>
+              <a:r>
+                <a:rPr lang="en-US" sz="1600" dirty="0">
+                  <a:latin typeface="Times New Roman" panose="02020603050405020304" pitchFamily="18" charset="0"/>
+                  <a:cs typeface="Times New Roman" panose="02020603050405020304" pitchFamily="18" charset="0"/>
+                </a:rPr>
+                <a:t>To Predict </a:t>
+              </a:r>
+            </a:p>
+            <a:p>
+              <a:pPr algn="ctr"/>
+              <a:r>
+                <a:rPr lang="en-US" sz="1600" dirty="0">
+                  <a:latin typeface="Times New Roman" panose="02020603050405020304" pitchFamily="18" charset="0"/>
+                  <a:cs typeface="Times New Roman" panose="02020603050405020304" pitchFamily="18" charset="0"/>
+                </a:rPr>
+                <a:t>Pixel Masks</a:t>
+              </a:r>
+            </a:p>
+          </p:txBody>
+        </p:sp>
+        <p:pic>
+          <p:nvPicPr>
+            <p:cNvPr id="1054" name="Picture 4" descr="U-NET: Computer Vision's neural network | DataScientest.com">
+              <a:extLst>
+                <a:ext uri="{FF2B5EF4-FFF2-40B4-BE49-F238E27FC236}">
+                  <a16:creationId xmlns:a16="http://schemas.microsoft.com/office/drawing/2014/main" id="{0A998F0C-4588-6FBD-3132-7BFF7F8844F7}"/>
+                </a:ext>
+              </a:extLst>
+            </p:cNvPr>
+            <p:cNvPicPr>
+              <a:picLocks noChangeAspect="1" noChangeArrowheads="1"/>
+            </p:cNvPicPr>
+            <p:nvPr/>
+          </p:nvPicPr>
+          <p:blipFill rotWithShape="1">
+            <a:blip r:embed="rId3">
+              <a:extLst>
+                <a:ext uri="{28A0092B-C50C-407E-A947-70E740481C1C}">
+                  <a14:useLocalDpi xmlns:a14="http://schemas.microsoft.com/office/drawing/2010/main" val="0"/>
+                </a:ext>
+              </a:extLst>
+            </a:blip>
+            <a:srcRect l="11097" t="11566" r="6311"/>
+            <a:stretch>
+              <a:fillRect/>
+            </a:stretch>
+          </p:blipFill>
+          <p:spPr bwMode="auto">
+            <a:xfrm>
+              <a:off x="6568039" y="5620211"/>
+              <a:ext cx="2093110" cy="1230001"/>
+            </a:xfrm>
+            <a:prstGeom prst="rect">
+              <a:avLst/>
+            </a:prstGeom>
+            <a:noFill/>
+            <a:extLst>
+              <a:ext uri="{909E8E84-426E-40DD-AFC4-6F175D3DCCD1}">
+                <a14:hiddenFill xmlns:a14="http://schemas.microsoft.com/office/drawing/2010/main">
+                  <a:solidFill>
+                    <a:srgbClr val="FFFFFF"/>
+                  </a:solidFill>
+                </a14:hiddenFill>
+              </a:ext>
+            </a:extLst>
+          </p:spPr>
+        </p:pic>
+        <p:cxnSp>
+          <p:nvCxnSpPr>
+            <p:cNvPr id="1056" name="Straight Arrow Connector 1055">
+              <a:extLst>
+                <a:ext uri="{FF2B5EF4-FFF2-40B4-BE49-F238E27FC236}">
+                  <a16:creationId xmlns:a16="http://schemas.microsoft.com/office/drawing/2014/main" id="{FA036DA7-7D8F-5603-6F58-9424BD00D304}"/>
+                </a:ext>
+              </a:extLst>
+            </p:cNvPr>
+            <p:cNvCxnSpPr>
+              <a:cxnSpLocks/>
+            </p:cNvCxnSpPr>
+            <p:nvPr/>
+          </p:nvCxnSpPr>
+          <p:spPr>
+            <a:xfrm>
+              <a:off x="5640583" y="6082853"/>
+              <a:ext cx="725006" cy="0"/>
+            </a:xfrm>
+            <a:prstGeom prst="straightConnector1">
+              <a:avLst/>
+            </a:prstGeom>
+            <a:ln>
+              <a:tailEnd type="triangle"/>
+            </a:ln>
+          </p:spPr>
+          <p:style>
+            <a:lnRef idx="2">
+              <a:schemeClr val="accent1"/>
+            </a:lnRef>
+            <a:fillRef idx="0">
+              <a:schemeClr val="accent1"/>
+            </a:fillRef>
+            <a:effectRef idx="1">
+              <a:schemeClr val="accent1"/>
+            </a:effectRef>
+            <a:fontRef idx="minor">
+              <a:schemeClr val="tx1"/>
+            </a:fontRef>
+          </p:style>
+        </p:cxnSp>
+        <p:sp>
+          <p:nvSpPr>
+            <p:cNvPr id="1057" name="TextBox 1056">
+              <a:extLst>
+                <a:ext uri="{FF2B5EF4-FFF2-40B4-BE49-F238E27FC236}">
+                  <a16:creationId xmlns:a16="http://schemas.microsoft.com/office/drawing/2014/main" id="{26C5FD25-13BA-E0A9-2E3D-414E0A1DE8F7}"/>
+                </a:ext>
+              </a:extLst>
+            </p:cNvPr>
+            <p:cNvSpPr txBox="1"/>
+            <p:nvPr/>
+          </p:nvSpPr>
+          <p:spPr>
+            <a:xfrm rot="16200000">
+              <a:off x="5553932" y="5502035"/>
+              <a:ext cx="818605" cy="523220"/>
+            </a:xfrm>
+            <a:prstGeom prst="rect">
+              <a:avLst/>
+            </a:prstGeom>
+            <a:noFill/>
+            <a:ln>
+              <a:noFill/>
+            </a:ln>
+            <a:effectLst/>
+            <a:scene3d>
+              <a:camera prst="orthographicFront">
+                <a:rot lat="0" lon="0" rev="0"/>
+              </a:camera>
+              <a:lightRig rig="contrasting" dir="t">
+                <a:rot lat="0" lon="0" rev="7800000"/>
+              </a:lightRig>
+            </a:scene3d>
+            <a:sp3d>
+              <a:bevelT w="139700" h="139700"/>
+            </a:sp3d>
+          </p:spPr>
+          <p:txBody>
+            <a:bodyPr wrap="square" rtlCol="0">
+              <a:spAutoFit/>
+            </a:bodyPr>
+            <a:lstStyle/>
+            <a:p>
+              <a:pPr algn="ctr"/>
+              <a:r>
+                <a:rPr lang="en-US" sz="1400" dirty="0">
+                  <a:latin typeface="Times New Roman" panose="02020603050405020304" pitchFamily="18" charset="0"/>
+                  <a:cs typeface="Times New Roman" panose="02020603050405020304" pitchFamily="18" charset="0"/>
+                </a:rPr>
+                <a:t>Weight Transfer</a:t>
+              </a:r>
+            </a:p>
+          </p:txBody>
+        </p:sp>
+        <p:sp>
+          <p:nvSpPr>
+            <p:cNvPr id="1058" name="TextBox 1057">
+              <a:extLst>
+                <a:ext uri="{FF2B5EF4-FFF2-40B4-BE49-F238E27FC236}">
+                  <a16:creationId xmlns:a16="http://schemas.microsoft.com/office/drawing/2014/main" id="{2D933523-73D3-14B9-8054-86A98B7E43C1}"/>
+                </a:ext>
+              </a:extLst>
+            </p:cNvPr>
+            <p:cNvSpPr txBox="1"/>
+            <p:nvPr/>
+          </p:nvSpPr>
+          <p:spPr>
+            <a:xfrm>
+              <a:off x="6349048" y="5135552"/>
+              <a:ext cx="989374" cy="584775"/>
+            </a:xfrm>
+            <a:prstGeom prst="rect">
+              <a:avLst/>
+            </a:prstGeom>
+            <a:noFill/>
+          </p:spPr>
+          <p:txBody>
+            <a:bodyPr wrap="none" rtlCol="0">
+              <a:spAutoFit/>
+            </a:bodyPr>
+            <a:lstStyle/>
+            <a:p>
+              <a:pPr algn="ctr"/>
+              <a:r>
+                <a:rPr lang="en-US" sz="1600" dirty="0" err="1">
+                  <a:latin typeface="Times New Roman" panose="02020603050405020304" pitchFamily="18" charset="0"/>
+                  <a:cs typeface="Times New Roman" panose="02020603050405020304" pitchFamily="18" charset="0"/>
+                </a:rPr>
+                <a:t>Xception</a:t>
+              </a:r>
+              <a:r>
+                <a:rPr lang="en-US" sz="1600" dirty="0">
+                  <a:latin typeface="Times New Roman" panose="02020603050405020304" pitchFamily="18" charset="0"/>
+                  <a:cs typeface="Times New Roman" panose="02020603050405020304" pitchFamily="18" charset="0"/>
+                </a:rPr>
+                <a:t> </a:t>
+              </a:r>
+            </a:p>
+            <a:p>
+              <a:pPr algn="ctr"/>
+              <a:r>
+                <a:rPr lang="en-US" sz="1600" dirty="0">
+                  <a:latin typeface="Times New Roman" panose="02020603050405020304" pitchFamily="18" charset="0"/>
+                  <a:cs typeface="Times New Roman" panose="02020603050405020304" pitchFamily="18" charset="0"/>
+                </a:rPr>
+                <a:t>Encoder</a:t>
+              </a:r>
+            </a:p>
+          </p:txBody>
+        </p:sp>
+        <p:sp>
+          <p:nvSpPr>
+            <p:cNvPr id="1059" name="TextBox 1058">
+              <a:extLst>
+                <a:ext uri="{FF2B5EF4-FFF2-40B4-BE49-F238E27FC236}">
+                  <a16:creationId xmlns:a16="http://schemas.microsoft.com/office/drawing/2014/main" id="{A3558C59-3512-8912-39E2-A8362C07817B}"/>
+                </a:ext>
+              </a:extLst>
+            </p:cNvPr>
+            <p:cNvSpPr txBox="1"/>
+            <p:nvPr/>
+          </p:nvSpPr>
+          <p:spPr>
+            <a:xfrm>
+              <a:off x="7507185" y="5114069"/>
+              <a:ext cx="1433406" cy="584775"/>
+            </a:xfrm>
+            <a:prstGeom prst="rect">
+              <a:avLst/>
+            </a:prstGeom>
+            <a:noFill/>
+          </p:spPr>
+          <p:txBody>
+            <a:bodyPr wrap="none" rtlCol="0">
+              <a:spAutoFit/>
+            </a:bodyPr>
+            <a:lstStyle/>
+            <a:p>
+              <a:pPr algn="ctr"/>
+              <a:r>
+                <a:rPr lang="en-US" sz="1600" dirty="0">
+                  <a:latin typeface="Times New Roman" panose="02020603050405020304" pitchFamily="18" charset="0"/>
+                  <a:cs typeface="Times New Roman" panose="02020603050405020304" pitchFamily="18" charset="0"/>
+                </a:rPr>
+                <a:t>CBAM </a:t>
+              </a:r>
+            </a:p>
+            <a:p>
+              <a:pPr algn="ctr"/>
+              <a:r>
+                <a:rPr lang="en-US" sz="1600" dirty="0">
+                  <a:latin typeface="Times New Roman" panose="02020603050405020304" pitchFamily="18" charset="0"/>
+                  <a:cs typeface="Times New Roman" panose="02020603050405020304" pitchFamily="18" charset="0"/>
+                </a:rPr>
+                <a:t>Based Decoder</a:t>
+              </a:r>
+            </a:p>
+          </p:txBody>
+        </p:sp>
+        <p:sp>
+          <p:nvSpPr>
+            <p:cNvPr id="1060" name="TextBox 1059">
+              <a:extLst>
+                <a:ext uri="{FF2B5EF4-FFF2-40B4-BE49-F238E27FC236}">
+                  <a16:creationId xmlns:a16="http://schemas.microsoft.com/office/drawing/2014/main" id="{392D6596-70AC-138C-A88E-C34C10BAB173}"/>
+                </a:ext>
+              </a:extLst>
+            </p:cNvPr>
+            <p:cNvSpPr txBox="1"/>
+            <p:nvPr/>
+          </p:nvSpPr>
+          <p:spPr>
+            <a:xfrm>
+              <a:off x="7222713" y="5287952"/>
+              <a:ext cx="385041" cy="338554"/>
+            </a:xfrm>
+            <a:prstGeom prst="rect">
+              <a:avLst/>
+            </a:prstGeom>
+            <a:noFill/>
+          </p:spPr>
+          <p:txBody>
+            <a:bodyPr wrap="none" rtlCol="0">
+              <a:spAutoFit/>
+            </a:bodyPr>
+            <a:lstStyle/>
+            <a:p>
+              <a:pPr algn="ctr"/>
+              <a:r>
+                <a:rPr lang="en-US" sz="1600" dirty="0">
+                  <a:latin typeface="Times New Roman" panose="02020603050405020304" pitchFamily="18" charset="0"/>
+                  <a:cs typeface="Times New Roman" panose="02020603050405020304" pitchFamily="18" charset="0"/>
+                  <a:sym typeface="Wingdings" panose="05000000000000000000" pitchFamily="2" charset="2"/>
+                </a:rPr>
+                <a:t></a:t>
+              </a:r>
+              <a:endParaRPr lang="en-US" sz="1600" dirty="0">
+                <a:latin typeface="Times New Roman" panose="02020603050405020304" pitchFamily="18" charset="0"/>
+                <a:cs typeface="Times New Roman" panose="02020603050405020304" pitchFamily="18" charset="0"/>
+              </a:endParaRPr>
+            </a:p>
+          </p:txBody>
+        </p:sp>
+        <p:sp>
+          <p:nvSpPr>
+            <p:cNvPr id="1061" name="Rectangle: Rounded Corners 1060">
+              <a:extLst>
+                <a:ext uri="{FF2B5EF4-FFF2-40B4-BE49-F238E27FC236}">
+                  <a16:creationId xmlns:a16="http://schemas.microsoft.com/office/drawing/2014/main" id="{DF51D6D6-7F4B-81D7-826B-91EEC9AF915C}"/>
+                </a:ext>
+              </a:extLst>
+            </p:cNvPr>
+            <p:cNvSpPr/>
+            <p:nvPr/>
+          </p:nvSpPr>
+          <p:spPr>
+            <a:xfrm>
+              <a:off x="6365589" y="5014487"/>
+              <a:ext cx="2533431" cy="1821554"/>
+            </a:xfrm>
+            <a:prstGeom prst="roundRect">
+              <a:avLst/>
+            </a:prstGeom>
+            <a:noFill/>
+            <a:ln>
+              <a:solidFill>
+                <a:schemeClr val="tx1"/>
+              </a:solidFill>
+              <a:prstDash val="dashDot"/>
+            </a:ln>
+          </p:spPr>
+          <p:style>
+            <a:lnRef idx="2">
+              <a:schemeClr val="accent6"/>
+            </a:lnRef>
+            <a:fillRef idx="1">
+              <a:schemeClr val="lt1"/>
+            </a:fillRef>
+            <a:effectRef idx="0">
+              <a:schemeClr val="accent6"/>
+            </a:effectRef>
+            <a:fontRef idx="minor">
+              <a:schemeClr val="dk1"/>
+            </a:fontRef>
+          </p:style>
+          <p:txBody>
+            <a:bodyPr rtlCol="0" anchor="ctr"/>
+            <a:lstStyle/>
+            <a:p>
+              <a:pPr algn="ctr"/>
+              <a:endParaRPr lang="en-US"/>
+            </a:p>
+          </p:txBody>
+        </p:sp>
+        <p:pic>
+          <p:nvPicPr>
+            <p:cNvPr id="1062" name="Picture 4" descr="U-NET: Computer Vision's neural network | DataScientest.com">
+              <a:extLst>
+                <a:ext uri="{FF2B5EF4-FFF2-40B4-BE49-F238E27FC236}">
+                  <a16:creationId xmlns:a16="http://schemas.microsoft.com/office/drawing/2014/main" id="{521B52F0-1DA6-7CB5-F0F3-9909AEE8AE98}"/>
+                </a:ext>
+              </a:extLst>
+            </p:cNvPr>
+            <p:cNvPicPr>
+              <a:picLocks noChangeAspect="1" noChangeArrowheads="1"/>
+            </p:cNvPicPr>
+            <p:nvPr/>
+          </p:nvPicPr>
+          <p:blipFill rotWithShape="1">
+            <a:blip r:embed="rId3">
+              <a:extLst>
+                <a:ext uri="{28A0092B-C50C-407E-A947-70E740481C1C}">
+                  <a14:useLocalDpi xmlns:a14="http://schemas.microsoft.com/office/drawing/2010/main" val="0"/>
+                </a:ext>
+              </a:extLst>
+            </a:blip>
+            <a:srcRect l="11097" t="11566" r="6311"/>
+            <a:stretch>
+              <a:fillRect/>
+            </a:stretch>
+          </p:blipFill>
+          <p:spPr bwMode="auto">
+            <a:xfrm>
+              <a:off x="9575504" y="5842099"/>
+              <a:ext cx="1450918" cy="852622"/>
+            </a:xfrm>
+            <a:prstGeom prst="rect">
+              <a:avLst/>
+            </a:prstGeom>
+            <a:noFill/>
+            <a:extLst>
+              <a:ext uri="{909E8E84-426E-40DD-AFC4-6F175D3DCCD1}">
+                <a14:hiddenFill xmlns:a14="http://schemas.microsoft.com/office/drawing/2010/main">
+                  <a:solidFill>
+                    <a:srgbClr val="FFFFFF"/>
+                  </a:solidFill>
+                </a14:hiddenFill>
+              </a:ext>
+            </a:extLst>
+          </p:spPr>
+        </p:pic>
+        <p:sp>
+          <p:nvSpPr>
+            <p:cNvPr id="1063" name="TextBox 1062">
+              <a:extLst>
+                <a:ext uri="{FF2B5EF4-FFF2-40B4-BE49-F238E27FC236}">
+                  <a16:creationId xmlns:a16="http://schemas.microsoft.com/office/drawing/2014/main" id="{1288F391-6EC4-93F9-829F-665CF7A2F5D8}"/>
+                </a:ext>
+              </a:extLst>
+            </p:cNvPr>
+            <p:cNvSpPr txBox="1"/>
+            <p:nvPr/>
+          </p:nvSpPr>
+          <p:spPr>
+            <a:xfrm>
+              <a:off x="9456010" y="5009708"/>
+              <a:ext cx="1604927" cy="830997"/>
+            </a:xfrm>
+            <a:prstGeom prst="rect">
+              <a:avLst/>
+            </a:prstGeom>
+            <a:noFill/>
+          </p:spPr>
+          <p:txBody>
+            <a:bodyPr wrap="none" rtlCol="0">
+              <a:spAutoFit/>
+            </a:bodyPr>
+            <a:lstStyle/>
+            <a:p>
+              <a:pPr algn="ctr"/>
+              <a:r>
+                <a:rPr lang="en-US" sz="1600" dirty="0">
+                  <a:latin typeface="Times New Roman" panose="02020603050405020304" pitchFamily="18" charset="0"/>
+                  <a:cs typeface="Times New Roman" panose="02020603050405020304" pitchFamily="18" charset="0"/>
+                </a:rPr>
+                <a:t>U-Net Based</a:t>
+              </a:r>
+            </a:p>
+            <a:p>
+              <a:pPr algn="ctr"/>
+              <a:r>
+                <a:rPr lang="en-US" sz="1600" dirty="0">
+                  <a:latin typeface="Times New Roman" panose="02020603050405020304" pitchFamily="18" charset="0"/>
+                  <a:cs typeface="Times New Roman" panose="02020603050405020304" pitchFamily="18" charset="0"/>
+                </a:rPr>
+                <a:t>Refiner </a:t>
+              </a:r>
+            </a:p>
+            <a:p>
+              <a:pPr algn="ctr"/>
+              <a:r>
+                <a:rPr lang="en-US" sz="1600" dirty="0">
+                  <a:latin typeface="Times New Roman" panose="02020603050405020304" pitchFamily="18" charset="0"/>
+                  <a:cs typeface="Times New Roman" panose="02020603050405020304" pitchFamily="18" charset="0"/>
+                </a:rPr>
+                <a:t>(~7M Parameter)</a:t>
+              </a:r>
+            </a:p>
+          </p:txBody>
+        </p:sp>
+        <p:sp>
+          <p:nvSpPr>
+            <p:cNvPr id="1064" name="Rectangle: Rounded Corners 1063">
+              <a:extLst>
+                <a:ext uri="{FF2B5EF4-FFF2-40B4-BE49-F238E27FC236}">
+                  <a16:creationId xmlns:a16="http://schemas.microsoft.com/office/drawing/2014/main" id="{08AB5DF2-5204-ABA9-6312-EAFB38BDC41D}"/>
+                </a:ext>
+              </a:extLst>
+            </p:cNvPr>
+            <p:cNvSpPr/>
+            <p:nvPr/>
+          </p:nvSpPr>
+          <p:spPr>
+            <a:xfrm>
+              <a:off x="9490522" y="5014487"/>
+              <a:ext cx="1535900" cy="1821554"/>
+            </a:xfrm>
+            <a:prstGeom prst="roundRect">
+              <a:avLst/>
+            </a:prstGeom>
+            <a:noFill/>
+            <a:ln>
+              <a:solidFill>
+                <a:schemeClr val="tx1"/>
+              </a:solidFill>
+              <a:prstDash val="dashDot"/>
+            </a:ln>
+          </p:spPr>
+          <p:style>
+            <a:lnRef idx="2">
+              <a:schemeClr val="accent6"/>
+            </a:lnRef>
+            <a:fillRef idx="1">
+              <a:schemeClr val="lt1"/>
+            </a:fillRef>
+            <a:effectRef idx="0">
+              <a:schemeClr val="accent6"/>
+            </a:effectRef>
+            <a:fontRef idx="minor">
+              <a:schemeClr val="dk1"/>
+            </a:fontRef>
+          </p:style>
+          <p:txBody>
+            <a:bodyPr rtlCol="0" anchor="ctr"/>
+            <a:lstStyle/>
+            <a:p>
+              <a:pPr algn="ctr"/>
+              <a:endParaRPr lang="en-US"/>
+            </a:p>
+          </p:txBody>
+        </p:sp>
+        <p:sp>
+          <p:nvSpPr>
+            <p:cNvPr id="1065" name="TextBox 1064">
+              <a:extLst>
+                <a:ext uri="{FF2B5EF4-FFF2-40B4-BE49-F238E27FC236}">
+                  <a16:creationId xmlns:a16="http://schemas.microsoft.com/office/drawing/2014/main" id="{86E86D10-C014-7620-F25E-9B0B8F2CB034}"/>
+                </a:ext>
+              </a:extLst>
+            </p:cNvPr>
+            <p:cNvSpPr txBox="1"/>
+            <p:nvPr/>
+          </p:nvSpPr>
+          <p:spPr>
+            <a:xfrm rot="16200000">
+              <a:off x="8413699" y="5383716"/>
+              <a:ext cx="1577005" cy="523220"/>
+            </a:xfrm>
+            <a:prstGeom prst="rect">
+              <a:avLst/>
+            </a:prstGeom>
+            <a:noFill/>
+            <a:ln>
+              <a:noFill/>
+            </a:ln>
+            <a:effectLst/>
+            <a:scene3d>
+              <a:camera prst="orthographicFront">
+                <a:rot lat="0" lon="0" rev="0"/>
+              </a:camera>
+              <a:lightRig rig="contrasting" dir="t">
+                <a:rot lat="0" lon="0" rev="7800000"/>
+              </a:lightRig>
+            </a:scene3d>
+            <a:sp3d>
+              <a:bevelT w="139700" h="139700"/>
+            </a:sp3d>
+          </p:spPr>
+          <p:txBody>
+            <a:bodyPr wrap="square" rtlCol="0">
+              <a:spAutoFit/>
+            </a:bodyPr>
+            <a:lstStyle/>
+            <a:p>
+              <a:pPr algn="ctr"/>
+              <a:r>
+                <a:rPr lang="en-US" sz="1400" dirty="0">
+                  <a:latin typeface="Times New Roman" panose="02020603050405020304" pitchFamily="18" charset="0"/>
+                  <a:cs typeface="Times New Roman" panose="02020603050405020304" pitchFamily="18" charset="0"/>
+                </a:rPr>
+                <a:t>Segmented </a:t>
+              </a:r>
+            </a:p>
+            <a:p>
+              <a:pPr algn="ctr"/>
+              <a:r>
+                <a:rPr lang="en-US" sz="1400" dirty="0">
+                  <a:latin typeface="Times New Roman" panose="02020603050405020304" pitchFamily="18" charset="0"/>
+                  <a:cs typeface="Times New Roman" panose="02020603050405020304" pitchFamily="18" charset="0"/>
+                </a:rPr>
+                <a:t>output</a:t>
+              </a:r>
+            </a:p>
+          </p:txBody>
+        </p:sp>
+        <p:cxnSp>
+          <p:nvCxnSpPr>
+            <p:cNvPr id="1067" name="Straight Arrow Connector 1066">
+              <a:extLst>
+                <a:ext uri="{FF2B5EF4-FFF2-40B4-BE49-F238E27FC236}">
+                  <a16:creationId xmlns:a16="http://schemas.microsoft.com/office/drawing/2014/main" id="{C5D7BA13-6E5C-AD6E-A7DC-D3FC1ED1B2FE}"/>
+                </a:ext>
+              </a:extLst>
+            </p:cNvPr>
+            <p:cNvCxnSpPr/>
+            <p:nvPr/>
+          </p:nvCxnSpPr>
+          <p:spPr>
+            <a:xfrm>
+              <a:off x="8899020" y="6076950"/>
+              <a:ext cx="591502" cy="0"/>
+            </a:xfrm>
+            <a:prstGeom prst="straightConnector1">
+              <a:avLst/>
+            </a:prstGeom>
+            <a:ln>
+              <a:tailEnd type="triangle"/>
+            </a:ln>
+          </p:spPr>
+          <p:style>
+            <a:lnRef idx="2">
+              <a:schemeClr val="accent1"/>
+            </a:lnRef>
+            <a:fillRef idx="0">
+              <a:schemeClr val="accent1"/>
+            </a:fillRef>
+            <a:effectRef idx="1">
+              <a:schemeClr val="accent1"/>
+            </a:effectRef>
+            <a:fontRef idx="minor">
+              <a:schemeClr val="tx1"/>
+            </a:fontRef>
+          </p:style>
+        </p:cxnSp>
+        <p:sp>
+          <p:nvSpPr>
+            <p:cNvPr id="1069" name="TextBox 1068">
+              <a:extLst>
+                <a:ext uri="{FF2B5EF4-FFF2-40B4-BE49-F238E27FC236}">
+                  <a16:creationId xmlns:a16="http://schemas.microsoft.com/office/drawing/2014/main" id="{8C3BB9B8-E42E-4329-E78A-4E3A3950E266}"/>
+                </a:ext>
+              </a:extLst>
+            </p:cNvPr>
+            <p:cNvSpPr txBox="1"/>
+            <p:nvPr/>
+          </p:nvSpPr>
+          <p:spPr>
+            <a:xfrm>
+              <a:off x="7213398" y="4742213"/>
+              <a:ext cx="818605" cy="305422"/>
+            </a:xfrm>
+            <a:prstGeom prst="rect">
+              <a:avLst/>
+            </a:prstGeom>
+            <a:noFill/>
+            <a:ln>
+              <a:noFill/>
+            </a:ln>
+            <a:effectLst/>
+            <a:scene3d>
+              <a:camera prst="orthographicFront">
+                <a:rot lat="0" lon="0" rev="0"/>
+              </a:camera>
+              <a:lightRig rig="contrasting" dir="t">
+                <a:rot lat="0" lon="0" rev="7800000"/>
+              </a:lightRig>
+            </a:scene3d>
+            <a:sp3d>
+              <a:bevelT w="139700" h="139700"/>
+            </a:sp3d>
+          </p:spPr>
+          <p:txBody>
+            <a:bodyPr wrap="square" rtlCol="0">
+              <a:spAutoFit/>
+            </a:bodyPr>
+            <a:lstStyle/>
+            <a:p>
+              <a:pPr algn="ctr"/>
+              <a:r>
+                <a:rPr lang="en-US" sz="1400" dirty="0">
+                  <a:latin typeface="Times New Roman" panose="02020603050405020304" pitchFamily="18" charset="0"/>
+                  <a:cs typeface="Times New Roman" panose="02020603050405020304" pitchFamily="18" charset="0"/>
+                </a:rPr>
+                <a:t>Stage 2</a:t>
+              </a:r>
+            </a:p>
+          </p:txBody>
+        </p:sp>
+        <p:sp>
+          <p:nvSpPr>
+            <p:cNvPr id="1070" name="TextBox 1069">
+              <a:extLst>
+                <a:ext uri="{FF2B5EF4-FFF2-40B4-BE49-F238E27FC236}">
+                  <a16:creationId xmlns:a16="http://schemas.microsoft.com/office/drawing/2014/main" id="{56CE8B69-035D-A02B-4726-B8AD4B97C0F0}"/>
+                </a:ext>
+              </a:extLst>
+            </p:cNvPr>
+            <p:cNvSpPr txBox="1"/>
+            <p:nvPr/>
+          </p:nvSpPr>
+          <p:spPr>
+            <a:xfrm>
+              <a:off x="9823248" y="4761263"/>
+              <a:ext cx="818605" cy="305422"/>
+            </a:xfrm>
+            <a:prstGeom prst="rect">
+              <a:avLst/>
+            </a:prstGeom>
+            <a:noFill/>
+            <a:ln>
+              <a:noFill/>
+            </a:ln>
+            <a:effectLst/>
+            <a:scene3d>
+              <a:camera prst="orthographicFront">
+                <a:rot lat="0" lon="0" rev="0"/>
+              </a:camera>
+              <a:lightRig rig="contrasting" dir="t">
+                <a:rot lat="0" lon="0" rev="7800000"/>
+              </a:lightRig>
+            </a:scene3d>
+            <a:sp3d>
+              <a:bevelT w="139700" h="139700"/>
+            </a:sp3d>
+          </p:spPr>
+          <p:txBody>
+            <a:bodyPr wrap="square" rtlCol="0">
+              <a:spAutoFit/>
+            </a:bodyPr>
+            <a:lstStyle/>
+            <a:p>
+              <a:pPr algn="ctr"/>
+              <a:r>
+                <a:rPr lang="en-US" sz="1400" dirty="0">
+                  <a:latin typeface="Times New Roman" panose="02020603050405020304" pitchFamily="18" charset="0"/>
+                  <a:cs typeface="Times New Roman" panose="02020603050405020304" pitchFamily="18" charset="0"/>
+                </a:rPr>
+                <a:t>Stage 3</a:t>
+              </a:r>
+            </a:p>
+          </p:txBody>
+        </p:sp>
+        <p:sp>
+          <p:nvSpPr>
+            <p:cNvPr id="1072" name="TextBox 1071">
+              <a:extLst>
+                <a:ext uri="{FF2B5EF4-FFF2-40B4-BE49-F238E27FC236}">
+                  <a16:creationId xmlns:a16="http://schemas.microsoft.com/office/drawing/2014/main" id="{18A42241-8FAA-25D3-C51B-D4DBC623E99E}"/>
+                </a:ext>
+              </a:extLst>
+            </p:cNvPr>
+            <p:cNvSpPr txBox="1"/>
+            <p:nvPr/>
+          </p:nvSpPr>
+          <p:spPr>
+            <a:xfrm>
+              <a:off x="4963168" y="4400991"/>
+              <a:ext cx="5153847" cy="338554"/>
+            </a:xfrm>
+            <a:prstGeom prst="rect">
+              <a:avLst/>
+            </a:prstGeom>
+            <a:noFill/>
+          </p:spPr>
+          <p:txBody>
+            <a:bodyPr wrap="none" rtlCol="0">
+              <a:spAutoFit/>
+            </a:bodyPr>
+            <a:lstStyle/>
+            <a:p>
+              <a:r>
+                <a:rPr lang="en-US" sz="1600" dirty="0">
+                  <a:latin typeface="Times New Roman" panose="02020603050405020304" pitchFamily="18" charset="0"/>
+                  <a:cs typeface="Times New Roman" panose="02020603050405020304" pitchFamily="18" charset="0"/>
+                </a:rPr>
+                <a:t>Three-Stage Attention-Enhanced Segmentation with Refiner</a:t>
+              </a:r>
+            </a:p>
+          </p:txBody>
+        </p:sp>
+        <p:pic>
+          <p:nvPicPr>
+            <p:cNvPr id="1074" name="Picture 1073" descr="A close-up of a red cell&#10;&#10;AI-generated content may be incorrect.">
+              <a:extLst>
+                <a:ext uri="{FF2B5EF4-FFF2-40B4-BE49-F238E27FC236}">
+                  <a16:creationId xmlns:a16="http://schemas.microsoft.com/office/drawing/2014/main" id="{29F7A866-BE52-7065-DA89-A45FD9DEA54E}"/>
+                </a:ext>
+              </a:extLst>
+            </p:cNvPr>
+            <p:cNvPicPr>
+              <a:picLocks noChangeAspect="1"/>
+            </p:cNvPicPr>
+            <p:nvPr/>
+          </p:nvPicPr>
+          <p:blipFill>
+            <a:blip r:embed="rId4">
+              <a:extLst>
+                <a:ext uri="{28A0092B-C50C-407E-A947-70E740481C1C}">
+                  <a14:useLocalDpi xmlns:a14="http://schemas.microsoft.com/office/drawing/2010/main" val="0"/>
+                </a:ext>
+              </a:extLst>
+            </a:blip>
+            <a:stretch>
+              <a:fillRect/>
+            </a:stretch>
+          </p:blipFill>
+          <p:spPr>
+            <a:xfrm>
+              <a:off x="11761052" y="4931748"/>
+              <a:ext cx="1743675" cy="1743675"/>
+            </a:xfrm>
+            <a:prstGeom prst="rect">
+              <a:avLst/>
+            </a:prstGeom>
+          </p:spPr>
+        </p:pic>
+        <p:cxnSp>
+          <p:nvCxnSpPr>
+            <p:cNvPr id="1077" name="Straight Arrow Connector 1076">
+              <a:extLst>
+                <a:ext uri="{FF2B5EF4-FFF2-40B4-BE49-F238E27FC236}">
+                  <a16:creationId xmlns:a16="http://schemas.microsoft.com/office/drawing/2014/main" id="{E9EAC77C-B6FD-4299-E445-0FD56A56B129}"/>
+                </a:ext>
+              </a:extLst>
+            </p:cNvPr>
+            <p:cNvCxnSpPr>
+              <a:cxnSpLocks/>
+            </p:cNvCxnSpPr>
+            <p:nvPr/>
+          </p:nvCxnSpPr>
+          <p:spPr>
+            <a:xfrm flipV="1">
+              <a:off x="11143157" y="6032186"/>
+              <a:ext cx="617895" cy="0"/>
+            </a:xfrm>
+            <a:prstGeom prst="straightConnector1">
+              <a:avLst/>
+            </a:prstGeom>
+            <a:ln>
+              <a:tailEnd type="triangle"/>
+            </a:ln>
+          </p:spPr>
+          <p:style>
+            <a:lnRef idx="2">
+              <a:schemeClr val="accent1"/>
+            </a:lnRef>
+            <a:fillRef idx="0">
+              <a:schemeClr val="accent1"/>
+            </a:fillRef>
+            <a:effectRef idx="1">
+              <a:schemeClr val="accent1"/>
+            </a:effectRef>
+            <a:fontRef idx="minor">
+              <a:schemeClr val="tx1"/>
+            </a:fontRef>
+          </p:style>
+        </p:cxnSp>
+        <p:sp>
+          <p:nvSpPr>
+            <p:cNvPr id="1078" name="TextBox 1077">
+              <a:extLst>
+                <a:ext uri="{FF2B5EF4-FFF2-40B4-BE49-F238E27FC236}">
+                  <a16:creationId xmlns:a16="http://schemas.microsoft.com/office/drawing/2014/main" id="{20FC9228-3B13-20AC-18CC-471B6C86FDA4}"/>
+                </a:ext>
+              </a:extLst>
+            </p:cNvPr>
+            <p:cNvSpPr txBox="1"/>
+            <p:nvPr/>
+          </p:nvSpPr>
+          <p:spPr>
+            <a:xfrm rot="16200000">
+              <a:off x="10842574" y="5202740"/>
+              <a:ext cx="1215056" cy="523220"/>
+            </a:xfrm>
+            <a:prstGeom prst="rect">
+              <a:avLst/>
+            </a:prstGeom>
+            <a:noFill/>
+            <a:ln>
+              <a:noFill/>
+            </a:ln>
+            <a:effectLst/>
+            <a:scene3d>
+              <a:camera prst="orthographicFront">
+                <a:rot lat="0" lon="0" rev="0"/>
+              </a:camera>
+              <a:lightRig rig="contrasting" dir="t">
+                <a:rot lat="0" lon="0" rev="7800000"/>
+              </a:lightRig>
+            </a:scene3d>
+            <a:sp3d>
+              <a:bevelT w="139700" h="139700"/>
+            </a:sp3d>
+          </p:spPr>
+          <p:txBody>
+            <a:bodyPr wrap="square" rtlCol="0">
+              <a:spAutoFit/>
+            </a:bodyPr>
+            <a:lstStyle/>
+            <a:p>
+              <a:r>
+                <a:rPr lang="en-US" sz="1400" dirty="0">
+                  <a:latin typeface="Times New Roman" panose="02020603050405020304" pitchFamily="18" charset="0"/>
+                  <a:cs typeface="Times New Roman" panose="02020603050405020304" pitchFamily="18" charset="0"/>
+                </a:rPr>
+                <a:t>Segmented </a:t>
+              </a:r>
+            </a:p>
+            <a:p>
+              <a:r>
+                <a:rPr lang="en-US" sz="1400" dirty="0">
+                  <a:latin typeface="Times New Roman" panose="02020603050405020304" pitchFamily="18" charset="0"/>
+                  <a:cs typeface="Times New Roman" panose="02020603050405020304" pitchFamily="18" charset="0"/>
+                </a:rPr>
+                <a:t>Final output</a:t>
+              </a:r>
+            </a:p>
+          </p:txBody>
+        </p:sp>
+        <p:grpSp>
+          <p:nvGrpSpPr>
+            <p:cNvPr id="1159" name="Group 1158">
+              <a:extLst>
+                <a:ext uri="{FF2B5EF4-FFF2-40B4-BE49-F238E27FC236}">
+                  <a16:creationId xmlns:a16="http://schemas.microsoft.com/office/drawing/2014/main" id="{4746D58F-021F-53EC-3BD1-6E70CD8BDE82}"/>
+                </a:ext>
+              </a:extLst>
+            </p:cNvPr>
+            <p:cNvGrpSpPr/>
+            <p:nvPr/>
+          </p:nvGrpSpPr>
+          <p:grpSpPr>
+            <a:xfrm>
+              <a:off x="11440880" y="7658127"/>
+              <a:ext cx="2384724" cy="1407661"/>
+              <a:chOff x="11440880" y="7658127"/>
+              <a:chExt cx="2384724" cy="1407661"/>
+            </a:xfrm>
+          </p:grpSpPr>
+          <p:sp>
+            <p:nvSpPr>
+              <p:cNvPr id="1153" name="Rectangle: Rounded Corners 1152">
+                <a:extLst>
+                  <a:ext uri="{FF2B5EF4-FFF2-40B4-BE49-F238E27FC236}">
+                    <a16:creationId xmlns:a16="http://schemas.microsoft.com/office/drawing/2014/main" id="{D4E05E05-EE07-839D-B41C-CAD97899A419}"/>
+                  </a:ext>
+                </a:extLst>
+              </p:cNvPr>
+              <p:cNvSpPr/>
+              <p:nvPr/>
+            </p:nvSpPr>
+            <p:spPr>
+              <a:xfrm>
+                <a:off x="11471543" y="7658127"/>
+                <a:ext cx="2354061" cy="1407661"/>
+              </a:xfrm>
+              <a:prstGeom prst="roundRect">
+                <a:avLst/>
+              </a:prstGeom>
+              <a:solidFill>
+                <a:srgbClr val="E8EEF2"/>
+              </a:solidFill>
+              <a:ln>
+                <a:solidFill>
+                  <a:srgbClr val="BAF0E7"/>
+                </a:solidFill>
+                <a:prstDash val="solid"/>
+              </a:ln>
+            </p:spPr>
+            <p:style>
+              <a:lnRef idx="2">
+                <a:schemeClr val="accent6"/>
+              </a:lnRef>
+              <a:fillRef idx="1">
+                <a:schemeClr val="lt1"/>
+              </a:fillRef>
+              <a:effectRef idx="0">
+                <a:schemeClr val="accent6"/>
+              </a:effectRef>
+              <a:fontRef idx="minor">
+                <a:schemeClr val="dk1"/>
+              </a:fontRef>
+            </p:style>
+            <p:txBody>
+              <a:bodyPr rtlCol="0" anchor="ctr"/>
+              <a:lstStyle/>
+              <a:p>
+                <a:pPr algn="ctr"/>
+                <a:endParaRPr lang="en-US"/>
+              </a:p>
+            </p:txBody>
+          </p:sp>
+          <p:sp>
+            <p:nvSpPr>
+              <p:cNvPr id="1152" name="TextBox 1151">
+                <a:extLst>
+                  <a:ext uri="{FF2B5EF4-FFF2-40B4-BE49-F238E27FC236}">
+                    <a16:creationId xmlns:a16="http://schemas.microsoft.com/office/drawing/2014/main" id="{0056AFF6-AAD6-7DD1-D049-28B2BF9ADAE9}"/>
+                  </a:ext>
+                </a:extLst>
+              </p:cNvPr>
+              <p:cNvSpPr txBox="1"/>
+              <p:nvPr/>
+            </p:nvSpPr>
+            <p:spPr>
+              <a:xfrm>
+                <a:off x="11440880" y="7700238"/>
+                <a:ext cx="2369296" cy="1323439"/>
+              </a:xfrm>
+              <a:prstGeom prst="rect">
+                <a:avLst/>
+              </a:prstGeom>
+              <a:noFill/>
+              <a:ln>
+                <a:noFill/>
+              </a:ln>
+            </p:spPr>
+            <p:txBody>
+              <a:bodyPr wrap="square" rtlCol="0">
+                <a:spAutoFit/>
+              </a:bodyPr>
+              <a:lstStyle/>
+              <a:p>
+                <a:pPr algn="ctr"/>
+                <a:r>
+                  <a:rPr lang="fr-FR" sz="1600" dirty="0" err="1">
+                    <a:latin typeface="Times New Roman" panose="02020603050405020304" pitchFamily="18" charset="0"/>
+                    <a:cs typeface="Times New Roman" panose="02020603050405020304" pitchFamily="18" charset="0"/>
+                  </a:rPr>
+                  <a:t>Comprehensive</a:t>
+                </a:r>
+                <a:r>
+                  <a:rPr lang="fr-FR" sz="1600" dirty="0">
+                    <a:latin typeface="Times New Roman" panose="02020603050405020304" pitchFamily="18" charset="0"/>
+                    <a:cs typeface="Times New Roman" panose="02020603050405020304" pitchFamily="18" charset="0"/>
+                  </a:rPr>
+                  <a:t> Image Augmentation (flip, </a:t>
+                </a:r>
+                <a:r>
+                  <a:rPr lang="fr-FR" sz="1600" dirty="0" err="1">
+                    <a:latin typeface="Times New Roman" panose="02020603050405020304" pitchFamily="18" charset="0"/>
+                    <a:cs typeface="Times New Roman" panose="02020603050405020304" pitchFamily="18" charset="0"/>
+                  </a:rPr>
+                  <a:t>rotate</a:t>
+                </a:r>
+                <a:r>
+                  <a:rPr lang="fr-FR" sz="1600" dirty="0">
+                    <a:latin typeface="Times New Roman" panose="02020603050405020304" pitchFamily="18" charset="0"/>
+                    <a:cs typeface="Times New Roman" panose="02020603050405020304" pitchFamily="18" charset="0"/>
+                  </a:rPr>
+                  <a:t>, </a:t>
+                </a:r>
+                <a:r>
+                  <a:rPr lang="fr-FR" sz="1600" dirty="0" err="1">
+                    <a:latin typeface="Times New Roman" panose="02020603050405020304" pitchFamily="18" charset="0"/>
+                    <a:cs typeface="Times New Roman" panose="02020603050405020304" pitchFamily="18" charset="0"/>
+                  </a:rPr>
+                  <a:t>scale</a:t>
+                </a:r>
+                <a:r>
+                  <a:rPr lang="fr-FR" sz="1600" dirty="0">
+                    <a:latin typeface="Times New Roman" panose="02020603050405020304" pitchFamily="18" charset="0"/>
+                    <a:cs typeface="Times New Roman" panose="02020603050405020304" pitchFamily="18" charset="0"/>
+                  </a:rPr>
+                  <a:t>, </a:t>
+                </a:r>
+                <a:r>
+                  <a:rPr lang="fr-FR" sz="1600" dirty="0" err="1">
+                    <a:latin typeface="Times New Roman" panose="02020603050405020304" pitchFamily="18" charset="0"/>
+                    <a:cs typeface="Times New Roman" panose="02020603050405020304" pitchFamily="18" charset="0"/>
+                  </a:rPr>
+                  <a:t>crop</a:t>
+                </a:r>
+                <a:r>
+                  <a:rPr lang="fr-FR" sz="1600" dirty="0">
+                    <a:latin typeface="Times New Roman" panose="02020603050405020304" pitchFamily="18" charset="0"/>
+                    <a:cs typeface="Times New Roman" panose="02020603050405020304" pitchFamily="18" charset="0"/>
+                  </a:rPr>
+                  <a:t>, </a:t>
+                </a:r>
+                <a:r>
+                  <a:rPr lang="fr-FR" sz="1600" dirty="0" err="1">
+                    <a:latin typeface="Times New Roman" panose="02020603050405020304" pitchFamily="18" charset="0"/>
+                    <a:cs typeface="Times New Roman" panose="02020603050405020304" pitchFamily="18" charset="0"/>
+                  </a:rPr>
+                  <a:t>color</a:t>
+                </a:r>
+                <a:r>
+                  <a:rPr lang="fr-FR" sz="1600" dirty="0">
+                    <a:latin typeface="Times New Roman" panose="02020603050405020304" pitchFamily="18" charset="0"/>
+                    <a:cs typeface="Times New Roman" panose="02020603050405020304" pitchFamily="18" charset="0"/>
+                  </a:rPr>
+                  <a:t> &amp; noise variations) for Class Balance</a:t>
+                </a:r>
+                <a:endParaRPr lang="en-US" sz="1600" dirty="0">
+                  <a:latin typeface="Times New Roman" panose="02020603050405020304" pitchFamily="18" charset="0"/>
+                  <a:cs typeface="Times New Roman" panose="02020603050405020304" pitchFamily="18" charset="0"/>
+                </a:endParaRPr>
+              </a:p>
+            </p:txBody>
+          </p:sp>
+        </p:grpSp>
+        <p:cxnSp>
+          <p:nvCxnSpPr>
+            <p:cNvPr id="1156" name="Straight Arrow Connector 1155">
+              <a:extLst>
+                <a:ext uri="{FF2B5EF4-FFF2-40B4-BE49-F238E27FC236}">
+                  <a16:creationId xmlns:a16="http://schemas.microsoft.com/office/drawing/2014/main" id="{43A6F238-FB4D-FEAD-4CF1-510161C5CC62}"/>
+                </a:ext>
+              </a:extLst>
+            </p:cNvPr>
+            <p:cNvCxnSpPr>
+              <a:cxnSpLocks/>
+              <a:stCxn id="1074" idx="2"/>
+              <a:endCxn id="1153" idx="0"/>
+            </p:cNvCxnSpPr>
+            <p:nvPr/>
+          </p:nvCxnSpPr>
+          <p:spPr>
+            <a:xfrm>
+              <a:off x="12632890" y="6675423"/>
+              <a:ext cx="15684" cy="982704"/>
+            </a:xfrm>
+            <a:prstGeom prst="straightConnector1">
+              <a:avLst/>
+            </a:prstGeom>
+            <a:ln>
+              <a:tailEnd type="triangle"/>
+            </a:ln>
+          </p:spPr>
+          <p:style>
+            <a:lnRef idx="2">
+              <a:schemeClr val="accent1"/>
+            </a:lnRef>
+            <a:fillRef idx="0">
+              <a:schemeClr val="accent1"/>
+            </a:fillRef>
+            <a:effectRef idx="1">
+              <a:schemeClr val="accent1"/>
+            </a:effectRef>
+            <a:fontRef idx="minor">
+              <a:schemeClr val="tx1"/>
+            </a:fontRef>
+          </p:style>
+        </p:cxnSp>
+        <p:sp>
+          <p:nvSpPr>
+            <p:cNvPr id="1157" name="TextBox 1156">
+              <a:extLst>
+                <a:ext uri="{FF2B5EF4-FFF2-40B4-BE49-F238E27FC236}">
+                  <a16:creationId xmlns:a16="http://schemas.microsoft.com/office/drawing/2014/main" id="{4BA8A93F-1C3E-59A2-F89E-7F741A01E30D}"/>
+                </a:ext>
+              </a:extLst>
+            </p:cNvPr>
+            <p:cNvSpPr txBox="1"/>
+            <p:nvPr/>
+          </p:nvSpPr>
+          <p:spPr>
+            <a:xfrm rot="16200000">
+              <a:off x="12325889" y="6853161"/>
+              <a:ext cx="1086658" cy="523220"/>
+            </a:xfrm>
+            <a:prstGeom prst="rect">
+              <a:avLst/>
+            </a:prstGeom>
+            <a:noFill/>
+            <a:ln>
+              <a:noFill/>
+            </a:ln>
+            <a:effectLst/>
+            <a:scene3d>
+              <a:camera prst="orthographicFront">
+                <a:rot lat="0" lon="0" rev="0"/>
+              </a:camera>
+              <a:lightRig rig="contrasting" dir="t">
+                <a:rot lat="0" lon="0" rev="7800000"/>
+              </a:lightRig>
+            </a:scene3d>
+            <a:sp3d>
+              <a:bevelT w="139700" h="139700"/>
+            </a:sp3d>
+          </p:spPr>
+          <p:txBody>
+            <a:bodyPr wrap="square" rtlCol="0">
+              <a:spAutoFit/>
+            </a:bodyPr>
+            <a:lstStyle/>
+            <a:p>
+              <a:pPr algn="ctr"/>
+              <a:r>
+                <a:rPr lang="en-US" sz="1400" dirty="0">
+                  <a:latin typeface="Times New Roman" panose="02020603050405020304" pitchFamily="18" charset="0"/>
+                  <a:cs typeface="Times New Roman" panose="02020603050405020304" pitchFamily="18" charset="0"/>
+                </a:rPr>
+                <a:t>Segmented </a:t>
+              </a:r>
+            </a:p>
+            <a:p>
+              <a:pPr algn="ctr"/>
+              <a:r>
+                <a:rPr lang="en-US" sz="1400" dirty="0">
+                  <a:latin typeface="Times New Roman" panose="02020603050405020304" pitchFamily="18" charset="0"/>
+                  <a:cs typeface="Times New Roman" panose="02020603050405020304" pitchFamily="18" charset="0"/>
+                </a:rPr>
+                <a:t>Dataset</a:t>
+              </a:r>
+            </a:p>
+          </p:txBody>
+        </p:sp>
+        <p:grpSp>
+          <p:nvGrpSpPr>
+            <p:cNvPr id="1163" name="Group 1162">
+              <a:extLst>
+                <a:ext uri="{FF2B5EF4-FFF2-40B4-BE49-F238E27FC236}">
+                  <a16:creationId xmlns:a16="http://schemas.microsoft.com/office/drawing/2014/main" id="{A2D9F8C5-DB96-1018-8E08-AFF2F0EFA793}"/>
+                </a:ext>
+              </a:extLst>
+            </p:cNvPr>
+            <p:cNvGrpSpPr/>
+            <p:nvPr/>
+          </p:nvGrpSpPr>
+          <p:grpSpPr>
+            <a:xfrm>
+              <a:off x="9433691" y="7658127"/>
+              <a:ext cx="1724913" cy="1407661"/>
+              <a:chOff x="11440880" y="7658127"/>
+              <a:chExt cx="2384724" cy="1407661"/>
+            </a:xfrm>
+          </p:grpSpPr>
+          <p:sp>
+            <p:nvSpPr>
+              <p:cNvPr id="1164" name="Rectangle: Rounded Corners 1163">
+                <a:extLst>
+                  <a:ext uri="{FF2B5EF4-FFF2-40B4-BE49-F238E27FC236}">
+                    <a16:creationId xmlns:a16="http://schemas.microsoft.com/office/drawing/2014/main" id="{6A33B855-0255-0AEB-FDE5-752652285477}"/>
+                  </a:ext>
+                </a:extLst>
+              </p:cNvPr>
+              <p:cNvSpPr/>
+              <p:nvPr/>
+            </p:nvSpPr>
+            <p:spPr>
+              <a:xfrm>
+                <a:off x="11471543" y="7658127"/>
+                <a:ext cx="2354061" cy="1407661"/>
+              </a:xfrm>
+              <a:prstGeom prst="roundRect">
+                <a:avLst/>
+              </a:prstGeom>
+              <a:solidFill>
+                <a:srgbClr val="E8EEF2"/>
+              </a:solidFill>
+              <a:ln>
+                <a:solidFill>
+                  <a:srgbClr val="BAF0E7"/>
+                </a:solidFill>
+                <a:prstDash val="solid"/>
+              </a:ln>
+            </p:spPr>
+            <p:style>
+              <a:lnRef idx="2">
+                <a:schemeClr val="accent6"/>
+              </a:lnRef>
+              <a:fillRef idx="1">
+                <a:schemeClr val="lt1"/>
+              </a:fillRef>
+              <a:effectRef idx="0">
+                <a:schemeClr val="accent6"/>
+              </a:effectRef>
+              <a:fontRef idx="minor">
+                <a:schemeClr val="dk1"/>
+              </a:fontRef>
+            </p:style>
+            <p:txBody>
+              <a:bodyPr rtlCol="0" anchor="ctr"/>
+              <a:lstStyle/>
+              <a:p>
+                <a:pPr algn="ctr"/>
+                <a:endParaRPr lang="en-US"/>
+              </a:p>
+            </p:txBody>
+          </p:sp>
+          <p:sp>
+            <p:nvSpPr>
+              <p:cNvPr id="1165" name="TextBox 1164">
+                <a:extLst>
+                  <a:ext uri="{FF2B5EF4-FFF2-40B4-BE49-F238E27FC236}">
+                    <a16:creationId xmlns:a16="http://schemas.microsoft.com/office/drawing/2014/main" id="{3C08872E-CCF8-4574-54E3-F424062194D4}"/>
+                  </a:ext>
+                </a:extLst>
+              </p:cNvPr>
+              <p:cNvSpPr txBox="1"/>
+              <p:nvPr/>
+            </p:nvSpPr>
+            <p:spPr>
+              <a:xfrm>
+                <a:off x="11440880" y="7966938"/>
+                <a:ext cx="2369296" cy="830997"/>
+              </a:xfrm>
+              <a:prstGeom prst="rect">
+                <a:avLst/>
+              </a:prstGeom>
+              <a:noFill/>
+              <a:ln>
+                <a:noFill/>
+              </a:ln>
+            </p:spPr>
+            <p:txBody>
+              <a:bodyPr wrap="square" rtlCol="0">
+                <a:spAutoFit/>
+              </a:bodyPr>
+              <a:lstStyle/>
+              <a:p>
+                <a:pPr algn="ctr"/>
+                <a:r>
+                  <a:rPr lang="fr-FR" sz="1600" dirty="0">
+                    <a:latin typeface="Times New Roman" panose="02020603050405020304" pitchFamily="18" charset="0"/>
+                    <a:cs typeface="Times New Roman" panose="02020603050405020304" pitchFamily="18" charset="0"/>
+                  </a:rPr>
+                  <a:t>Apply CLAHE for </a:t>
+                </a:r>
+                <a:r>
+                  <a:rPr lang="fr-FR" sz="1600" dirty="0" err="1">
+                    <a:latin typeface="Times New Roman" panose="02020603050405020304" pitchFamily="18" charset="0"/>
+                    <a:cs typeface="Times New Roman" panose="02020603050405020304" pitchFamily="18" charset="0"/>
+                  </a:rPr>
+                  <a:t>leisson</a:t>
+                </a:r>
+                <a:r>
+                  <a:rPr lang="fr-FR" sz="1600" dirty="0">
+                    <a:latin typeface="Times New Roman" panose="02020603050405020304" pitchFamily="18" charset="0"/>
+                    <a:cs typeface="Times New Roman" panose="02020603050405020304" pitchFamily="18" charset="0"/>
+                  </a:rPr>
+                  <a:t> </a:t>
+                </a:r>
+                <a:r>
+                  <a:rPr lang="fr-FR" sz="1600" dirty="0" err="1">
+                    <a:latin typeface="Times New Roman" panose="02020603050405020304" pitchFamily="18" charset="0"/>
+                    <a:cs typeface="Times New Roman" panose="02020603050405020304" pitchFamily="18" charset="0"/>
+                  </a:rPr>
+                  <a:t>Enhancement</a:t>
+                </a:r>
+                <a:endParaRPr lang="fr-FR" sz="1600" dirty="0">
+                  <a:latin typeface="Times New Roman" panose="02020603050405020304" pitchFamily="18" charset="0"/>
+                  <a:cs typeface="Times New Roman" panose="02020603050405020304" pitchFamily="18" charset="0"/>
+                </a:endParaRPr>
+              </a:p>
+            </p:txBody>
+          </p:sp>
+        </p:grpSp>
+        <p:cxnSp>
+          <p:nvCxnSpPr>
+            <p:cNvPr id="1168" name="Straight Arrow Connector 1167">
+              <a:extLst>
+                <a:ext uri="{FF2B5EF4-FFF2-40B4-BE49-F238E27FC236}">
+                  <a16:creationId xmlns:a16="http://schemas.microsoft.com/office/drawing/2014/main" id="{95D99326-989E-30D0-07F9-0B23DD4EFBB8}"/>
+                </a:ext>
+              </a:extLst>
+            </p:cNvPr>
+            <p:cNvCxnSpPr>
+              <a:stCxn id="1152" idx="1"/>
+              <a:endCxn id="1165" idx="3"/>
+            </p:cNvCxnSpPr>
+            <p:nvPr/>
+          </p:nvCxnSpPr>
+          <p:spPr>
+            <a:xfrm flipH="1">
+              <a:off x="11147445" y="8361958"/>
+              <a:ext cx="293435" cy="0"/>
+            </a:xfrm>
+            <a:prstGeom prst="straightConnector1">
+              <a:avLst/>
+            </a:prstGeom>
+            <a:ln>
+              <a:tailEnd type="triangle"/>
+            </a:ln>
+          </p:spPr>
+          <p:style>
+            <a:lnRef idx="2">
+              <a:schemeClr val="accent1"/>
+            </a:lnRef>
+            <a:fillRef idx="0">
+              <a:schemeClr val="accent1"/>
+            </a:fillRef>
+            <a:effectRef idx="1">
+              <a:schemeClr val="accent1"/>
+            </a:effectRef>
+            <a:fontRef idx="minor">
+              <a:schemeClr val="tx1"/>
+            </a:fontRef>
+          </p:style>
+        </p:cxnSp>
+        <p:sp>
+          <p:nvSpPr>
+            <p:cNvPr id="1169" name="Cube 1168">
+              <a:extLst>
+                <a:ext uri="{FF2B5EF4-FFF2-40B4-BE49-F238E27FC236}">
+                  <a16:creationId xmlns:a16="http://schemas.microsoft.com/office/drawing/2014/main" id="{831A85DA-B9B8-AA69-7A2F-27A83B23ED6D}"/>
+                </a:ext>
+              </a:extLst>
+            </p:cNvPr>
+            <p:cNvSpPr/>
+            <p:nvPr/>
+          </p:nvSpPr>
+          <p:spPr>
+            <a:xfrm>
+              <a:off x="7866488" y="7824111"/>
+              <a:ext cx="1103582" cy="1087104"/>
+            </a:xfrm>
+            <a:prstGeom prst="cube">
+              <a:avLst/>
+            </a:prstGeom>
+            <a:solidFill>
+              <a:srgbClr val="DCE6EC"/>
+            </a:solidFill>
+            <a:ln>
+              <a:solidFill>
+                <a:srgbClr val="D8BEEC"/>
+              </a:solidFill>
+            </a:ln>
+          </p:spPr>
+          <p:style>
+            <a:lnRef idx="2">
+              <a:schemeClr val="accent1">
+                <a:shade val="15000"/>
+              </a:schemeClr>
+            </a:lnRef>
+            <a:fillRef idx="1">
+              <a:schemeClr val="accent1"/>
+            </a:fillRef>
+            <a:effectRef idx="0">
+              <a:schemeClr val="accent1"/>
+            </a:effectRef>
+            <a:fontRef idx="minor">
+              <a:schemeClr val="lt1"/>
+            </a:fontRef>
+          </p:style>
+          <p:txBody>
+            <a:bodyPr rtlCol="0" anchor="ctr"/>
+            <a:lstStyle/>
+            <a:p>
+              <a:pPr algn="ctr"/>
+              <a:endParaRPr lang="en-US"/>
+            </a:p>
+          </p:txBody>
+        </p:sp>
+        <p:sp>
+          <p:nvSpPr>
+            <p:cNvPr id="1170" name="TextBox 1169">
+              <a:extLst>
+                <a:ext uri="{FF2B5EF4-FFF2-40B4-BE49-F238E27FC236}">
+                  <a16:creationId xmlns:a16="http://schemas.microsoft.com/office/drawing/2014/main" id="{7D20E997-5C76-CE6E-12BA-9590BF11BB39}"/>
+                </a:ext>
+              </a:extLst>
+            </p:cNvPr>
+            <p:cNvSpPr txBox="1"/>
+            <p:nvPr/>
+          </p:nvSpPr>
+          <p:spPr>
+            <a:xfrm>
+              <a:off x="7481658" y="7013193"/>
+              <a:ext cx="1967078" cy="830997"/>
+            </a:xfrm>
+            <a:prstGeom prst="rect">
+              <a:avLst/>
+            </a:prstGeom>
+            <a:noFill/>
+          </p:spPr>
+          <p:txBody>
+            <a:bodyPr wrap="none" rtlCol="0">
+              <a:spAutoFit/>
+            </a:bodyPr>
+            <a:lstStyle/>
+            <a:p>
+              <a:pPr algn="ctr"/>
+              <a:r>
+                <a:rPr lang="en-US" sz="1600" dirty="0" err="1">
+                  <a:latin typeface="Times New Roman" panose="02020603050405020304" pitchFamily="18" charset="0"/>
+                  <a:cs typeface="Times New Roman" panose="02020603050405020304" pitchFamily="18" charset="0"/>
+                </a:rPr>
+                <a:t>ConvNextSmall</a:t>
+              </a:r>
+              <a:endParaRPr lang="en-US" sz="1600" dirty="0">
+                <a:latin typeface="Times New Roman" panose="02020603050405020304" pitchFamily="18" charset="0"/>
+                <a:cs typeface="Times New Roman" panose="02020603050405020304" pitchFamily="18" charset="0"/>
+              </a:endParaRPr>
+            </a:p>
+            <a:p>
+              <a:pPr algn="ctr"/>
+              <a:r>
+                <a:rPr lang="en-US" sz="1600" dirty="0">
+                  <a:latin typeface="Times New Roman" panose="02020603050405020304" pitchFamily="18" charset="0"/>
+                  <a:cs typeface="Times New Roman" panose="02020603050405020304" pitchFamily="18" charset="0"/>
+                </a:rPr>
+                <a:t>Classifier with </a:t>
+              </a:r>
+            </a:p>
+            <a:p>
+              <a:pPr algn="ctr"/>
+              <a:r>
+                <a:rPr lang="en-US" sz="1600" dirty="0">
+                  <a:latin typeface="Times New Roman" panose="02020603050405020304" pitchFamily="18" charset="0"/>
+                  <a:cs typeface="Times New Roman" panose="02020603050405020304" pitchFamily="18" charset="0"/>
+                </a:rPr>
+                <a:t>Coordinate Attention </a:t>
+              </a:r>
+            </a:p>
+          </p:txBody>
+        </p:sp>
+        <p:cxnSp>
+          <p:nvCxnSpPr>
+            <p:cNvPr id="1172" name="Straight Arrow Connector 1171">
+              <a:extLst>
+                <a:ext uri="{FF2B5EF4-FFF2-40B4-BE49-F238E27FC236}">
+                  <a16:creationId xmlns:a16="http://schemas.microsoft.com/office/drawing/2014/main" id="{2849C3BA-6952-9DEB-AB0A-32F3EFFBBDE8}"/>
+                </a:ext>
+              </a:extLst>
+            </p:cNvPr>
+            <p:cNvCxnSpPr>
+              <a:stCxn id="1165" idx="1"/>
+            </p:cNvCxnSpPr>
+            <p:nvPr/>
+          </p:nvCxnSpPr>
+          <p:spPr>
+            <a:xfrm flipH="1" flipV="1">
+              <a:off x="8920455" y="8361958"/>
+              <a:ext cx="513236" cy="0"/>
+            </a:xfrm>
+            <a:prstGeom prst="straightConnector1">
+              <a:avLst/>
+            </a:prstGeom>
+            <a:ln>
+              <a:tailEnd type="triangle"/>
+            </a:ln>
+          </p:spPr>
+          <p:style>
+            <a:lnRef idx="2">
+              <a:schemeClr val="accent1"/>
+            </a:lnRef>
+            <a:fillRef idx="0">
+              <a:schemeClr val="accent1"/>
+            </a:fillRef>
+            <a:effectRef idx="1">
+              <a:schemeClr val="accent1"/>
+            </a:effectRef>
+            <a:fontRef idx="minor">
+              <a:schemeClr val="tx1"/>
+            </a:fontRef>
+          </p:style>
+        </p:cxnSp>
+        <p:grpSp>
+          <p:nvGrpSpPr>
+            <p:cNvPr id="1175" name="Group 1174">
+              <a:extLst>
+                <a:ext uri="{FF2B5EF4-FFF2-40B4-BE49-F238E27FC236}">
+                  <a16:creationId xmlns:a16="http://schemas.microsoft.com/office/drawing/2014/main" id="{8903A4C2-5161-6388-D3D7-F792EA9F8018}"/>
+                </a:ext>
+              </a:extLst>
+            </p:cNvPr>
+            <p:cNvGrpSpPr/>
+            <p:nvPr/>
+          </p:nvGrpSpPr>
+          <p:grpSpPr>
+            <a:xfrm>
+              <a:off x="6888593" y="7489077"/>
+              <a:ext cx="369745" cy="1697975"/>
+              <a:chOff x="6888593" y="7641477"/>
+              <a:chExt cx="369745" cy="1697975"/>
+            </a:xfrm>
+          </p:grpSpPr>
+          <p:sp>
+            <p:nvSpPr>
+              <p:cNvPr id="1174" name="Rectangle: Rounded Corners 1173">
+                <a:extLst>
+                  <a:ext uri="{FF2B5EF4-FFF2-40B4-BE49-F238E27FC236}">
+                    <a16:creationId xmlns:a16="http://schemas.microsoft.com/office/drawing/2014/main" id="{92B9799B-95AD-1732-9377-15550E6E1D06}"/>
+                  </a:ext>
+                </a:extLst>
+              </p:cNvPr>
+              <p:cNvSpPr/>
+              <p:nvPr/>
+            </p:nvSpPr>
+            <p:spPr>
+              <a:xfrm>
+                <a:off x="6888593" y="7641477"/>
+                <a:ext cx="369745" cy="1697975"/>
+              </a:xfrm>
+              <a:prstGeom prst="roundRect">
+                <a:avLst/>
+              </a:prstGeom>
+              <a:solidFill>
+                <a:srgbClr val="DCE6EC"/>
+              </a:solidFill>
+              <a:ln>
+                <a:solidFill>
+                  <a:schemeClr val="accent6">
+                    <a:lumMod val="20000"/>
+                    <a:lumOff val="80000"/>
+                  </a:schemeClr>
+                </a:solidFill>
+              </a:ln>
+              <a:effectLst/>
+              <a:scene3d>
+                <a:camera prst="orthographicFront">
+                  <a:rot lat="0" lon="0" rev="0"/>
+                </a:camera>
+                <a:lightRig rig="contrasting" dir="t">
+                  <a:rot lat="0" lon="0" rev="7800000"/>
+                </a:lightRig>
+              </a:scene3d>
+              <a:sp3d>
+                <a:bevelT w="139700" h="139700"/>
+              </a:sp3d>
+            </p:spPr>
+            <p:style>
+              <a:lnRef idx="2">
+                <a:schemeClr val="accent1">
+                  <a:shade val="15000"/>
+                </a:schemeClr>
+              </a:lnRef>
+              <a:fillRef idx="1">
+                <a:schemeClr val="accent1"/>
+              </a:fillRef>
+              <a:effectRef idx="0">
+                <a:schemeClr val="accent1"/>
+              </a:effectRef>
+              <a:fontRef idx="minor">
+                <a:schemeClr val="lt1"/>
+              </a:fontRef>
+            </p:style>
+            <p:txBody>
+              <a:bodyPr rtlCol="0" anchor="ctr"/>
+              <a:lstStyle/>
+              <a:p>
+                <a:pPr algn="ctr"/>
+                <a:endParaRPr lang="en-US" dirty="0"/>
+              </a:p>
+            </p:txBody>
+          </p:sp>
+          <p:sp>
+            <p:nvSpPr>
+              <p:cNvPr id="1173" name="TextBox 1172">
+                <a:extLst>
+                  <a:ext uri="{FF2B5EF4-FFF2-40B4-BE49-F238E27FC236}">
+                    <a16:creationId xmlns:a16="http://schemas.microsoft.com/office/drawing/2014/main" id="{02F6110D-4D22-EBE6-ADEF-E976EB7293EB}"/>
+                  </a:ext>
+                </a:extLst>
+              </p:cNvPr>
+              <p:cNvSpPr txBox="1"/>
+              <p:nvPr/>
+            </p:nvSpPr>
+            <p:spPr>
+              <a:xfrm rot="16200000">
+                <a:off x="6262490" y="8325587"/>
+                <a:ext cx="1630575" cy="338554"/>
+              </a:xfrm>
+              <a:prstGeom prst="rect">
+                <a:avLst/>
+              </a:prstGeom>
+              <a:noFill/>
+            </p:spPr>
+            <p:txBody>
+              <a:bodyPr wrap="none" rtlCol="0">
+                <a:spAutoFit/>
+              </a:bodyPr>
+              <a:lstStyle/>
+              <a:p>
+                <a:r>
+                  <a:rPr lang="en-US" sz="1600" dirty="0">
+                    <a:latin typeface="Times New Roman" panose="02020603050405020304" pitchFamily="18" charset="0"/>
+                    <a:cs typeface="Times New Roman" panose="02020603050405020304" pitchFamily="18" charset="0"/>
+                  </a:rPr>
+                  <a:t>Classified Output</a:t>
+                </a:r>
+              </a:p>
+            </p:txBody>
+          </p:sp>
+        </p:grpSp>
+        <p:cxnSp>
+          <p:nvCxnSpPr>
+            <p:cNvPr id="1177" name="Straight Arrow Connector 1176">
+              <a:extLst>
+                <a:ext uri="{FF2B5EF4-FFF2-40B4-BE49-F238E27FC236}">
+                  <a16:creationId xmlns:a16="http://schemas.microsoft.com/office/drawing/2014/main" id="{AA6383CB-F55B-D564-3D30-8296CC2DBA78}"/>
+                </a:ext>
+              </a:extLst>
+            </p:cNvPr>
+            <p:cNvCxnSpPr>
+              <a:stCxn id="1169" idx="2"/>
+              <a:endCxn id="1174" idx="3"/>
+            </p:cNvCxnSpPr>
+            <p:nvPr/>
+          </p:nvCxnSpPr>
+          <p:spPr>
+            <a:xfrm flipH="1" flipV="1">
+              <a:off x="7258338" y="8338065"/>
+              <a:ext cx="608150" cy="0"/>
+            </a:xfrm>
+            <a:prstGeom prst="straightConnector1">
+              <a:avLst/>
+            </a:prstGeom>
+            <a:ln>
+              <a:tailEnd type="triangle"/>
+            </a:ln>
+          </p:spPr>
+          <p:style>
+            <a:lnRef idx="2">
+              <a:schemeClr val="accent1"/>
+            </a:lnRef>
+            <a:fillRef idx="0">
+              <a:schemeClr val="accent1"/>
+            </a:fillRef>
+            <a:effectRef idx="1">
+              <a:schemeClr val="accent1"/>
+            </a:effectRef>
+            <a:fontRef idx="minor">
+              <a:schemeClr val="tx1"/>
+            </a:fontRef>
+          </p:style>
+        </p:cxnSp>
+        <p:pic>
+          <p:nvPicPr>
+            <p:cNvPr id="1179" name="Picture 1178" descr="A collage of images of a heart&#10;&#10;AI-generated content may be incorrect.">
+              <a:extLst>
+                <a:ext uri="{FF2B5EF4-FFF2-40B4-BE49-F238E27FC236}">
+                  <a16:creationId xmlns:a16="http://schemas.microsoft.com/office/drawing/2014/main" id="{1EA523B8-E282-614A-DC46-6D6F334E01EF}"/>
+                </a:ext>
+              </a:extLst>
+            </p:cNvPr>
+            <p:cNvPicPr>
+              <a:picLocks noChangeAspect="1"/>
+            </p:cNvPicPr>
+            <p:nvPr/>
+          </p:nvPicPr>
+          <p:blipFill>
+            <a:blip r:embed="rId5">
+              <a:extLst>
+                <a:ext uri="{28A0092B-C50C-407E-A947-70E740481C1C}">
+                  <a14:useLocalDpi xmlns:a14="http://schemas.microsoft.com/office/drawing/2010/main" val="0"/>
+                </a:ext>
+              </a:extLst>
+            </a:blip>
+            <a:srcRect l="49801" t="66060"/>
+            <a:stretch>
+              <a:fillRect/>
+            </a:stretch>
+          </p:blipFill>
+          <p:spPr>
+            <a:xfrm>
+              <a:off x="4289820" y="7192142"/>
+              <a:ext cx="1948272" cy="2064306"/>
+            </a:xfrm>
+            <a:prstGeom prst="rect">
+              <a:avLst/>
+            </a:prstGeom>
+          </p:spPr>
+        </p:pic>
+        <p:cxnSp>
+          <p:nvCxnSpPr>
+            <p:cNvPr id="1181" name="Straight Arrow Connector 1180">
+              <a:extLst>
+                <a:ext uri="{FF2B5EF4-FFF2-40B4-BE49-F238E27FC236}">
+                  <a16:creationId xmlns:a16="http://schemas.microsoft.com/office/drawing/2014/main" id="{E646108B-7DCD-6DD9-A51C-1D206DDA2E15}"/>
+                </a:ext>
+              </a:extLst>
+            </p:cNvPr>
+            <p:cNvCxnSpPr>
+              <a:cxnSpLocks/>
+            </p:cNvCxnSpPr>
+            <p:nvPr/>
+          </p:nvCxnSpPr>
+          <p:spPr>
+            <a:xfrm flipH="1" flipV="1">
+              <a:off x="6238092" y="8319545"/>
+              <a:ext cx="650501" cy="0"/>
+            </a:xfrm>
+            <a:prstGeom prst="straightConnector1">
+              <a:avLst/>
+            </a:prstGeom>
+            <a:ln>
+              <a:tailEnd type="triangle"/>
+            </a:ln>
+          </p:spPr>
+          <p:style>
+            <a:lnRef idx="2">
+              <a:schemeClr val="accent1"/>
+            </a:lnRef>
+            <a:fillRef idx="0">
+              <a:schemeClr val="accent1"/>
+            </a:fillRef>
+            <a:effectRef idx="1">
+              <a:schemeClr val="accent1"/>
+            </a:effectRef>
+            <a:fontRef idx="minor">
+              <a:schemeClr val="tx1"/>
+            </a:fontRef>
+          </p:style>
+        </p:cxnSp>
+        <p:sp>
+          <p:nvSpPr>
+            <p:cNvPr id="1183" name="TextBox 1182">
+              <a:extLst>
+                <a:ext uri="{FF2B5EF4-FFF2-40B4-BE49-F238E27FC236}">
+                  <a16:creationId xmlns:a16="http://schemas.microsoft.com/office/drawing/2014/main" id="{9B55254F-B850-B3DA-1F54-B434BA8010C9}"/>
+                </a:ext>
+              </a:extLst>
+            </p:cNvPr>
+            <p:cNvSpPr txBox="1"/>
+            <p:nvPr/>
+          </p:nvSpPr>
+          <p:spPr>
+            <a:xfrm rot="16200000">
+              <a:off x="3053916" y="8031027"/>
+              <a:ext cx="2027927" cy="584775"/>
+            </a:xfrm>
+            <a:prstGeom prst="rect">
+              <a:avLst/>
+            </a:prstGeom>
+            <a:noFill/>
+          </p:spPr>
+          <p:txBody>
+            <a:bodyPr wrap="none" rtlCol="0">
+              <a:spAutoFit/>
+            </a:bodyPr>
+            <a:lstStyle/>
+            <a:p>
+              <a:pPr algn="ctr"/>
+              <a:r>
+                <a:rPr lang="en-US" sz="1600" dirty="0" err="1">
+                  <a:latin typeface="Times New Roman" panose="02020603050405020304" pitchFamily="18" charset="0"/>
+                  <a:cs typeface="Times New Roman" panose="02020603050405020304" pitchFamily="18" charset="0"/>
+                </a:rPr>
+                <a:t>GradCam</a:t>
+              </a:r>
+              <a:r>
+                <a:rPr lang="en-US" sz="1600" dirty="0">
+                  <a:latin typeface="Times New Roman" panose="02020603050405020304" pitchFamily="18" charset="0"/>
+                  <a:cs typeface="Times New Roman" panose="02020603050405020304" pitchFamily="18" charset="0"/>
+                </a:rPr>
+                <a:t>++ heatmap</a:t>
+              </a:r>
+            </a:p>
+            <a:p>
+              <a:pPr algn="ctr"/>
+              <a:r>
+                <a:rPr lang="en-US" sz="1600" dirty="0">
+                  <a:latin typeface="Times New Roman" panose="02020603050405020304" pitchFamily="18" charset="0"/>
+                  <a:cs typeface="Times New Roman" panose="02020603050405020304" pitchFamily="18" charset="0"/>
+                </a:rPr>
+                <a:t>With confidence score</a:t>
+              </a:r>
+            </a:p>
+          </p:txBody>
+        </p:sp>
+        <p:cxnSp>
+          <p:nvCxnSpPr>
+            <p:cNvPr id="1187" name="Connector: Elbow 1186">
+              <a:extLst>
+                <a:ext uri="{FF2B5EF4-FFF2-40B4-BE49-F238E27FC236}">
+                  <a16:creationId xmlns:a16="http://schemas.microsoft.com/office/drawing/2014/main" id="{2938F191-4A66-49FB-CFC7-57FB96FC30E0}"/>
+                </a:ext>
+              </a:extLst>
+            </p:cNvPr>
+            <p:cNvCxnSpPr>
+              <a:stCxn id="1027" idx="2"/>
+              <a:endCxn id="1071" idx="1"/>
+            </p:cNvCxnSpPr>
+            <p:nvPr/>
+          </p:nvCxnSpPr>
+          <p:spPr>
+            <a:xfrm rot="5400000" flipH="1" flipV="1">
+              <a:off x="2983221" y="5453057"/>
+              <a:ext cx="353284" cy="1109773"/>
+            </a:xfrm>
+            <a:prstGeom prst="bentConnector4">
+              <a:avLst>
+                <a:gd name="adj1" fmla="val 97061"/>
+                <a:gd name="adj2" fmla="val 28"/>
+              </a:avLst>
+            </a:prstGeom>
+            <a:ln>
+              <a:tailEnd type="triangle"/>
+            </a:ln>
+          </p:spPr>
+          <p:style>
+            <a:lnRef idx="2">
+              <a:schemeClr val="accent1"/>
+            </a:lnRef>
+            <a:fillRef idx="0">
+              <a:schemeClr val="accent1"/>
+            </a:fillRef>
+            <a:effectRef idx="1">
+              <a:schemeClr val="accent1"/>
+            </a:effectRef>
+            <a:fontRef idx="minor">
+              <a:schemeClr val="tx1"/>
+            </a:fontRef>
+          </p:style>
+        </p:cxnSp>
+        <p:sp>
+          <p:nvSpPr>
+            <p:cNvPr id="1190" name="TextBox 1189">
+              <a:extLst>
+                <a:ext uri="{FF2B5EF4-FFF2-40B4-BE49-F238E27FC236}">
+                  <a16:creationId xmlns:a16="http://schemas.microsoft.com/office/drawing/2014/main" id="{5C763451-9108-7D05-8C4D-B74C9636FFD3}"/>
+                </a:ext>
+              </a:extLst>
+            </p:cNvPr>
+            <p:cNvSpPr txBox="1"/>
+            <p:nvPr/>
+          </p:nvSpPr>
+          <p:spPr>
+            <a:xfrm>
+              <a:off x="2085253" y="8019645"/>
+              <a:ext cx="1226618" cy="1077218"/>
+            </a:xfrm>
+            <a:prstGeom prst="rect">
+              <a:avLst/>
+            </a:prstGeom>
+            <a:noFill/>
+          </p:spPr>
+          <p:txBody>
+            <a:bodyPr wrap="none" rtlCol="0">
+              <a:spAutoFit/>
+            </a:bodyPr>
+            <a:lstStyle/>
+            <a:p>
+              <a:r>
+                <a:rPr lang="en-US" sz="1600" dirty="0">
+                  <a:latin typeface="Times New Roman" panose="02020603050405020304" pitchFamily="18" charset="0"/>
+                  <a:cs typeface="Times New Roman" panose="02020603050405020304" pitchFamily="18" charset="0"/>
+                </a:rPr>
+                <a:t>ISIC 2017,</a:t>
+              </a:r>
+            </a:p>
+            <a:p>
+              <a:r>
+                <a:rPr lang="en-US" sz="1600" dirty="0">
+                  <a:latin typeface="Times New Roman" panose="02020603050405020304" pitchFamily="18" charset="0"/>
+                  <a:cs typeface="Times New Roman" panose="02020603050405020304" pitchFamily="18" charset="0"/>
+                </a:rPr>
+                <a:t>ISIC 2018,</a:t>
+              </a:r>
+            </a:p>
+            <a:p>
+              <a:r>
+                <a:rPr lang="en-US" sz="1600" dirty="0">
+                  <a:latin typeface="Times New Roman" panose="02020603050405020304" pitchFamily="18" charset="0"/>
+                  <a:cs typeface="Times New Roman" panose="02020603050405020304" pitchFamily="18" charset="0"/>
+                </a:rPr>
+                <a:t>HAM10000,</a:t>
+              </a:r>
+            </a:p>
+            <a:p>
+              <a:r>
+                <a:rPr lang="en-US" sz="1600" dirty="0">
+                  <a:latin typeface="Times New Roman" panose="02020603050405020304" pitchFamily="18" charset="0"/>
+                  <a:cs typeface="Times New Roman" panose="02020603050405020304" pitchFamily="18" charset="0"/>
+                </a:rPr>
+                <a:t>MILK10K</a:t>
+              </a:r>
+            </a:p>
+          </p:txBody>
+        </p:sp>
+        <p:sp>
+          <p:nvSpPr>
+            <p:cNvPr id="1193" name="Rectangle: Rounded Corners 1192">
+              <a:extLst>
+                <a:ext uri="{FF2B5EF4-FFF2-40B4-BE49-F238E27FC236}">
+                  <a16:creationId xmlns:a16="http://schemas.microsoft.com/office/drawing/2014/main" id="{71F6928C-F299-0F1F-46C2-1ED382F9F848}"/>
+                </a:ext>
+              </a:extLst>
+            </p:cNvPr>
+            <p:cNvSpPr/>
+            <p:nvPr/>
+          </p:nvSpPr>
+          <p:spPr>
+            <a:xfrm>
+              <a:off x="3902947" y="9749103"/>
+              <a:ext cx="4397737" cy="2178088"/>
+            </a:xfrm>
+            <a:prstGeom prst="roundRect">
+              <a:avLst>
+                <a:gd name="adj" fmla="val 8151"/>
+              </a:avLst>
+            </a:prstGeom>
+            <a:solidFill>
+              <a:srgbClr val="E8EEF2"/>
+            </a:solidFill>
+            <a:ln>
+              <a:solidFill>
+                <a:srgbClr val="D8BEEC"/>
+              </a:solidFill>
+            </a:ln>
+          </p:spPr>
+          <p:style>
+            <a:lnRef idx="2">
+              <a:schemeClr val="accent1">
+                <a:shade val="15000"/>
+              </a:schemeClr>
+            </a:lnRef>
+            <a:fillRef idx="1">
+              <a:schemeClr val="accent1"/>
+            </a:fillRef>
+            <a:effectRef idx="0">
+              <a:schemeClr val="accent1"/>
+            </a:effectRef>
+            <a:fontRef idx="minor">
+              <a:schemeClr val="lt1"/>
+            </a:fontRef>
+          </p:style>
+          <p:txBody>
+            <a:bodyPr rtlCol="0" anchor="ctr"/>
+            <a:lstStyle/>
+            <a:p>
+              <a:pPr algn="ctr"/>
+              <a:endParaRPr lang="en-US"/>
+            </a:p>
+          </p:txBody>
+        </p:sp>
+        <p:sp>
+          <p:nvSpPr>
+            <p:cNvPr id="1194" name="TextBox 1193">
+              <a:extLst>
+                <a:ext uri="{FF2B5EF4-FFF2-40B4-BE49-F238E27FC236}">
+                  <a16:creationId xmlns:a16="http://schemas.microsoft.com/office/drawing/2014/main" id="{DA7DB7DD-6030-7D56-11CF-585A924C6635}"/>
+                </a:ext>
+              </a:extLst>
+            </p:cNvPr>
+            <p:cNvSpPr txBox="1"/>
+            <p:nvPr/>
+          </p:nvSpPr>
+          <p:spPr>
+            <a:xfrm>
+              <a:off x="3843175" y="9420853"/>
+              <a:ext cx="2539478" cy="338554"/>
+            </a:xfrm>
+            <a:prstGeom prst="rect">
+              <a:avLst/>
+            </a:prstGeom>
+            <a:noFill/>
+          </p:spPr>
+          <p:txBody>
+            <a:bodyPr wrap="none" rtlCol="0">
+              <a:spAutoFit/>
+            </a:bodyPr>
+            <a:lstStyle/>
+            <a:p>
+              <a:pPr algn="ctr"/>
+              <a:r>
+                <a:rPr lang="en-US" sz="1600" dirty="0">
+                  <a:latin typeface="Times New Roman" panose="02020603050405020304" pitchFamily="18" charset="0"/>
+                  <a:cs typeface="Times New Roman" panose="02020603050405020304" pitchFamily="18" charset="0"/>
+                </a:rPr>
+                <a:t>Segmentation Model Result:</a:t>
+              </a:r>
+            </a:p>
+          </p:txBody>
+        </p:sp>
+        <p:sp>
+          <p:nvSpPr>
+            <p:cNvPr id="1197" name="Rectangle 8">
+              <a:extLst>
+                <a:ext uri="{FF2B5EF4-FFF2-40B4-BE49-F238E27FC236}">
+                  <a16:creationId xmlns:a16="http://schemas.microsoft.com/office/drawing/2014/main" id="{B7092F71-9279-F996-019F-EA9AEA7CA8EB}"/>
+                </a:ext>
+              </a:extLst>
+            </p:cNvPr>
+            <p:cNvSpPr>
+              <a:spLocks noChangeArrowheads="1"/>
+            </p:cNvSpPr>
+            <p:nvPr/>
+          </p:nvSpPr>
+          <p:spPr bwMode="auto">
+            <a:xfrm>
+              <a:off x="3860740" y="9801939"/>
+              <a:ext cx="4457509" cy="2062103"/>
+            </a:xfrm>
+            <a:prstGeom prst="rect">
+              <a:avLst/>
+            </a:prstGeom>
+            <a:noFill/>
+            <a:ln>
+              <a:noFill/>
+            </a:ln>
+            <a:effectLst/>
+            <a:extLst>
+              <a:ext uri="{909E8E84-426E-40DD-AFC4-6F175D3DCCD1}">
+                <a14:hiddenFill xmlns:a14="http://schemas.microsoft.com/office/drawing/2010/main">
+                  <a:solidFill>
+                    <a:schemeClr val="accent1"/>
+                  </a:solidFill>
+                </a14:hiddenFill>
+              </a:ext>
+              <a:ext uri="{91240B29-F687-4F45-9708-019B960494DF}">
+                <a14:hiddenLine xmlns:a14="http://schemas.microsoft.com/office/drawing/2010/main" w="9525">
+                  <a:solidFill>
+                    <a:schemeClr val="tx1"/>
+                  </a:solidFill>
+                  <a:miter lim="800000"/>
+                  <a:headEnd/>
+                  <a:tailEnd/>
+                </a14:hiddenLine>
+              </a:ext>
+              <a:ext uri="{AF507438-7753-43E0-B8FC-AC1667EBCBE1}">
+                <a14:hiddenEffects xmlns:a14="http://schemas.microsoft.com/office/drawing/2010/main">
+                  <a:effectLst>
+                    <a:outerShdw dist="35921" dir="2700000" algn="ctr" rotWithShape="0">
+                      <a:schemeClr val="bg2"/>
+                    </a:outerShdw>
+                  </a:effectLst>
+                </a14:hiddenEffects>
+              </a:ext>
+            </a:extLst>
+          </p:spPr>
+          <p:txBody>
+            <a:bodyPr vert="horz" wrap="square" lIns="91440" tIns="45720" rIns="91440" bIns="45720" numCol="1" anchor="ctr" anchorCtr="0" compatLnSpc="1">
+              <a:prstTxWarp prst="textNoShape">
+                <a:avLst/>
+              </a:prstTxWarp>
+              <a:spAutoFit/>
+            </a:bodyPr>
+            <a:lstStyle/>
+            <a:p>
+              <a:pPr marL="285750" marR="0" lvl="0" indent="-285750" algn="l" defTabSz="914400" rtl="0" eaLnBrk="0" fontAlgn="base" latinLnBrk="0" hangingPunct="0">
+                <a:lnSpc>
+                  <a:spcPct val="100000"/>
+                </a:lnSpc>
+                <a:spcBef>
+                  <a:spcPct val="0"/>
+                </a:spcBef>
+                <a:spcAft>
+                  <a:spcPct val="0"/>
+                </a:spcAft>
+                <a:buClrTx/>
+                <a:buSzTx/>
+                <a:buFont typeface="Arial" panose="020B0604020202020204" pitchFamily="34" charset="0"/>
+                <a:buChar char="•"/>
+                <a:tabLst/>
+              </a:pPr>
+              <a:r>
+                <a:rPr kumimoji="0" lang="en-US" altLang="en-US" sz="1600" b="1" i="0" u="none" strike="noStrike" cap="none" normalizeH="0" baseline="0" dirty="0">
+                  <a:ln>
+                    <a:noFill/>
+                  </a:ln>
+                  <a:solidFill>
+                    <a:schemeClr val="tx1"/>
+                  </a:solidFill>
+                  <a:effectLst/>
+                  <a:latin typeface="Times New Roman" panose="02020603050405020304" pitchFamily="18" charset="0"/>
+                  <a:cs typeface="Times New Roman" panose="02020603050405020304" pitchFamily="18" charset="0"/>
+                </a:rPr>
+                <a:t>Training Dataset:</a:t>
+              </a:r>
+              <a:r>
+                <a:rPr kumimoji="0" lang="en-US" altLang="en-US" sz="1600" b="0" i="0" u="none" strike="noStrike" cap="none" normalizeH="0" baseline="0" dirty="0">
+                  <a:ln>
+                    <a:noFill/>
+                  </a:ln>
+                  <a:solidFill>
+                    <a:schemeClr val="tx1"/>
+                  </a:solidFill>
+                  <a:effectLst/>
+                  <a:latin typeface="Times New Roman" panose="02020603050405020304" pitchFamily="18" charset="0"/>
+                  <a:cs typeface="Times New Roman" panose="02020603050405020304" pitchFamily="18" charset="0"/>
+                </a:rPr>
+                <a:t> ISIC 2018 (with 10% hold-out test set) — </a:t>
+              </a:r>
+              <a:r>
+                <a:rPr kumimoji="0" lang="en-US" altLang="en-US" sz="1600" b="0" i="1" u="none" strike="noStrike" cap="none" normalizeH="0" baseline="0" dirty="0">
+                  <a:ln>
+                    <a:noFill/>
+                  </a:ln>
+                  <a:solidFill>
+                    <a:schemeClr val="tx1"/>
+                  </a:solidFill>
+                  <a:effectLst/>
+                  <a:latin typeface="Times New Roman" panose="02020603050405020304" pitchFamily="18" charset="0"/>
+                  <a:cs typeface="Times New Roman" panose="02020603050405020304" pitchFamily="18" charset="0"/>
+                </a:rPr>
+                <a:t>Dice = 90.28</a:t>
+              </a:r>
+              <a:r>
+                <a:rPr kumimoji="0" lang="en-US" altLang="en-US" sz="1600" b="0" i="0" u="none" strike="noStrike" cap="none" normalizeH="0" baseline="0" dirty="0">
+                  <a:ln>
+                    <a:noFill/>
+                  </a:ln>
+                  <a:solidFill>
+                    <a:schemeClr val="tx1"/>
+                  </a:solidFill>
+                  <a:effectLst/>
+                  <a:latin typeface="Times New Roman" panose="02020603050405020304" pitchFamily="18" charset="0"/>
+                  <a:cs typeface="Times New Roman" panose="02020603050405020304" pitchFamily="18" charset="0"/>
+                </a:rPr>
+                <a:t>, </a:t>
+              </a:r>
+              <a:r>
+                <a:rPr kumimoji="0" lang="en-US" altLang="en-US" sz="1600" b="0" i="1" u="none" strike="noStrike" cap="none" normalizeH="0" baseline="0" dirty="0" err="1">
+                  <a:ln>
+                    <a:noFill/>
+                  </a:ln>
+                  <a:solidFill>
+                    <a:schemeClr val="tx1"/>
+                  </a:solidFill>
+                  <a:effectLst/>
+                  <a:latin typeface="Times New Roman" panose="02020603050405020304" pitchFamily="18" charset="0"/>
+                  <a:cs typeface="Times New Roman" panose="02020603050405020304" pitchFamily="18" charset="0"/>
+                </a:rPr>
+                <a:t>IoU</a:t>
+              </a:r>
+              <a:r>
+                <a:rPr kumimoji="0" lang="en-US" altLang="en-US" sz="1600" b="0" i="1" u="none" strike="noStrike" cap="none" normalizeH="0" baseline="0" dirty="0">
+                  <a:ln>
+                    <a:noFill/>
+                  </a:ln>
+                  <a:solidFill>
+                    <a:schemeClr val="tx1"/>
+                  </a:solidFill>
+                  <a:effectLst/>
+                  <a:latin typeface="Times New Roman" panose="02020603050405020304" pitchFamily="18" charset="0"/>
+                  <a:cs typeface="Times New Roman" panose="02020603050405020304" pitchFamily="18" charset="0"/>
+                </a:rPr>
+                <a:t> = 84.18</a:t>
+              </a:r>
+              <a:r>
+                <a:rPr kumimoji="0" lang="en-US" altLang="en-US" sz="1600" b="0" i="0" u="none" strike="noStrike" cap="none" normalizeH="0" baseline="0" dirty="0">
+                  <a:ln>
+                    <a:noFill/>
+                  </a:ln>
+                  <a:solidFill>
+                    <a:schemeClr val="tx1"/>
+                  </a:solidFill>
+                  <a:effectLst/>
+                  <a:latin typeface="Times New Roman" panose="02020603050405020304" pitchFamily="18" charset="0"/>
+                  <a:cs typeface="Times New Roman" panose="02020603050405020304" pitchFamily="18" charset="0"/>
+                </a:rPr>
+                <a:t>, </a:t>
+              </a:r>
+              <a:r>
+                <a:rPr kumimoji="0" lang="en-US" altLang="en-US" sz="1600" b="0" i="1" u="none" strike="noStrike" cap="none" normalizeH="0" baseline="0" dirty="0">
+                  <a:ln>
+                    <a:noFill/>
+                  </a:ln>
+                  <a:solidFill>
+                    <a:schemeClr val="tx1"/>
+                  </a:solidFill>
+                  <a:effectLst/>
+                  <a:latin typeface="Times New Roman" panose="02020603050405020304" pitchFamily="18" charset="0"/>
+                  <a:cs typeface="Times New Roman" panose="02020603050405020304" pitchFamily="18" charset="0"/>
+                </a:rPr>
+                <a:t>Accuracy = 95.60%</a:t>
+              </a:r>
+              <a:r>
+                <a:rPr kumimoji="0" lang="en-US" altLang="en-US" sz="1600" b="0" i="0" u="none" strike="noStrike" cap="none" normalizeH="0" baseline="0" dirty="0">
+                  <a:ln>
+                    <a:noFill/>
+                  </a:ln>
+                  <a:solidFill>
+                    <a:schemeClr val="tx1"/>
+                  </a:solidFill>
+                  <a:effectLst/>
+                  <a:latin typeface="Times New Roman" panose="02020603050405020304" pitchFamily="18" charset="0"/>
+                  <a:cs typeface="Times New Roman" panose="02020603050405020304" pitchFamily="18" charset="0"/>
+                </a:rPr>
+                <a:t>, </a:t>
+              </a:r>
+              <a:r>
+                <a:rPr kumimoji="0" lang="en-US" altLang="en-US" sz="1600" b="0" i="1" u="none" strike="noStrike" cap="none" normalizeH="0" baseline="0" dirty="0">
+                  <a:ln>
+                    <a:noFill/>
+                  </a:ln>
+                  <a:solidFill>
+                    <a:schemeClr val="tx1"/>
+                  </a:solidFill>
+                  <a:effectLst/>
+                  <a:latin typeface="Times New Roman" panose="02020603050405020304" pitchFamily="18" charset="0"/>
+                  <a:cs typeface="Times New Roman" panose="02020603050405020304" pitchFamily="18" charset="0"/>
+                </a:rPr>
+                <a:t>95% CI (Dice) = 88.87–91.52</a:t>
+              </a:r>
+              <a:r>
+                <a:rPr kumimoji="0" lang="en-US" altLang="en-US" sz="1600" b="0" i="0" u="none" strike="noStrike" cap="none" normalizeH="0" baseline="0" dirty="0">
+                  <a:ln>
+                    <a:noFill/>
+                  </a:ln>
+                  <a:solidFill>
+                    <a:schemeClr val="tx1"/>
+                  </a:solidFill>
+                  <a:effectLst/>
+                  <a:latin typeface="Times New Roman" panose="02020603050405020304" pitchFamily="18" charset="0"/>
+                  <a:cs typeface="Times New Roman" panose="02020603050405020304" pitchFamily="18" charset="0"/>
+                </a:rPr>
+                <a:t>.</a:t>
+              </a:r>
+            </a:p>
+            <a:p>
+              <a:pPr marL="285750" marR="0" lvl="0" indent="-285750" algn="l" defTabSz="914400" rtl="0" eaLnBrk="0" fontAlgn="base" latinLnBrk="0" hangingPunct="0">
+                <a:lnSpc>
+                  <a:spcPct val="100000"/>
+                </a:lnSpc>
+                <a:spcBef>
+                  <a:spcPct val="0"/>
+                </a:spcBef>
+                <a:spcAft>
+                  <a:spcPct val="0"/>
+                </a:spcAft>
+                <a:buClrTx/>
+                <a:buSzTx/>
+                <a:buFont typeface="Arial" panose="020B0604020202020204" pitchFamily="34" charset="0"/>
+                <a:buChar char="•"/>
+                <a:tabLst/>
+              </a:pPr>
+              <a:r>
+                <a:rPr kumimoji="0" lang="en-US" altLang="en-US" sz="1600" b="1" i="0" u="none" strike="noStrike" cap="none" normalizeH="0" baseline="0" dirty="0">
+                  <a:ln>
+                    <a:noFill/>
+                  </a:ln>
+                  <a:solidFill>
+                    <a:schemeClr val="tx1"/>
+                  </a:solidFill>
+                  <a:effectLst/>
+                  <a:latin typeface="Times New Roman" panose="02020603050405020304" pitchFamily="18" charset="0"/>
+                  <a:cs typeface="Times New Roman" panose="02020603050405020304" pitchFamily="18" charset="0"/>
+                </a:rPr>
+                <a:t>Robustness Evaluation:</a:t>
+              </a:r>
+              <a:r>
+                <a:rPr kumimoji="0" lang="en-US" altLang="en-US" sz="1600" b="0" i="0" u="none" strike="noStrike" cap="none" normalizeH="0" baseline="0" dirty="0">
+                  <a:ln>
+                    <a:noFill/>
+                  </a:ln>
+                  <a:solidFill>
+                    <a:schemeClr val="tx1"/>
+                  </a:solidFill>
+                  <a:effectLst/>
+                  <a:latin typeface="Times New Roman" panose="02020603050405020304" pitchFamily="18" charset="0"/>
+                  <a:cs typeface="Times New Roman" panose="02020603050405020304" pitchFamily="18" charset="0"/>
+                </a:rPr>
+                <a:t> Tested on ISIC 2017 (100% hold-out test set) — </a:t>
+              </a:r>
+              <a:r>
+                <a:rPr kumimoji="0" lang="en-US" altLang="en-US" sz="1600" b="0" i="1" u="none" strike="noStrike" cap="none" normalizeH="0" baseline="0" dirty="0">
+                  <a:ln>
+                    <a:noFill/>
+                  </a:ln>
+                  <a:solidFill>
+                    <a:schemeClr val="tx1"/>
+                  </a:solidFill>
+                  <a:effectLst/>
+                  <a:latin typeface="Times New Roman" panose="02020603050405020304" pitchFamily="18" charset="0"/>
+                  <a:cs typeface="Times New Roman" panose="02020603050405020304" pitchFamily="18" charset="0"/>
+                </a:rPr>
+                <a:t>Dice = 91.57</a:t>
+              </a:r>
+              <a:r>
+                <a:rPr kumimoji="0" lang="en-US" altLang="en-US" sz="1600" b="0" i="0" u="none" strike="noStrike" cap="none" normalizeH="0" baseline="0" dirty="0">
+                  <a:ln>
+                    <a:noFill/>
+                  </a:ln>
+                  <a:solidFill>
+                    <a:schemeClr val="tx1"/>
+                  </a:solidFill>
+                  <a:effectLst/>
+                  <a:latin typeface="Times New Roman" panose="02020603050405020304" pitchFamily="18" charset="0"/>
+                  <a:cs typeface="Times New Roman" panose="02020603050405020304" pitchFamily="18" charset="0"/>
+                </a:rPr>
+                <a:t>, </a:t>
+              </a:r>
+              <a:r>
+                <a:rPr kumimoji="0" lang="en-US" altLang="en-US" sz="1600" b="0" i="1" u="none" strike="noStrike" cap="none" normalizeH="0" baseline="0" dirty="0" err="1">
+                  <a:ln>
+                    <a:noFill/>
+                  </a:ln>
+                  <a:solidFill>
+                    <a:schemeClr val="tx1"/>
+                  </a:solidFill>
+                  <a:effectLst/>
+                  <a:latin typeface="Times New Roman" panose="02020603050405020304" pitchFamily="18" charset="0"/>
+                  <a:cs typeface="Times New Roman" panose="02020603050405020304" pitchFamily="18" charset="0"/>
+                </a:rPr>
+                <a:t>IoU</a:t>
+              </a:r>
+              <a:r>
+                <a:rPr kumimoji="0" lang="en-US" altLang="en-US" sz="1600" b="0" i="1" u="none" strike="noStrike" cap="none" normalizeH="0" baseline="0" dirty="0">
+                  <a:ln>
+                    <a:noFill/>
+                  </a:ln>
+                  <a:solidFill>
+                    <a:schemeClr val="tx1"/>
+                  </a:solidFill>
+                  <a:effectLst/>
+                  <a:latin typeface="Times New Roman" panose="02020603050405020304" pitchFamily="18" charset="0"/>
+                  <a:cs typeface="Times New Roman" panose="02020603050405020304" pitchFamily="18" charset="0"/>
+                </a:rPr>
+                <a:t> = 85.15</a:t>
+              </a:r>
+              <a:r>
+                <a:rPr kumimoji="0" lang="en-US" altLang="en-US" sz="1600" b="0" i="0" u="none" strike="noStrike" cap="none" normalizeH="0" baseline="0" dirty="0">
+                  <a:ln>
+                    <a:noFill/>
+                  </a:ln>
+                  <a:solidFill>
+                    <a:schemeClr val="tx1"/>
+                  </a:solidFill>
+                  <a:effectLst/>
+                  <a:latin typeface="Times New Roman" panose="02020603050405020304" pitchFamily="18" charset="0"/>
+                  <a:cs typeface="Times New Roman" panose="02020603050405020304" pitchFamily="18" charset="0"/>
+                </a:rPr>
+                <a:t>, </a:t>
+              </a:r>
+              <a:r>
+                <a:rPr kumimoji="0" lang="en-US" altLang="en-US" sz="1600" b="0" i="1" u="none" strike="noStrike" cap="none" normalizeH="0" baseline="0" dirty="0">
+                  <a:ln>
+                    <a:noFill/>
+                  </a:ln>
+                  <a:solidFill>
+                    <a:schemeClr val="tx1"/>
+                  </a:solidFill>
+                  <a:effectLst/>
+                  <a:latin typeface="Times New Roman" panose="02020603050405020304" pitchFamily="18" charset="0"/>
+                  <a:cs typeface="Times New Roman" panose="02020603050405020304" pitchFamily="18" charset="0"/>
+                </a:rPr>
+                <a:t>Accuracy = 97.07%</a:t>
+              </a:r>
+              <a:r>
+                <a:rPr kumimoji="0" lang="en-US" altLang="en-US" sz="1600" b="0" i="0" u="none" strike="noStrike" cap="none" normalizeH="0" baseline="0" dirty="0">
+                  <a:ln>
+                    <a:noFill/>
+                  </a:ln>
+                  <a:solidFill>
+                    <a:schemeClr val="tx1"/>
+                  </a:solidFill>
+                  <a:effectLst/>
+                  <a:latin typeface="Times New Roman" panose="02020603050405020304" pitchFamily="18" charset="0"/>
+                  <a:cs typeface="Times New Roman" panose="02020603050405020304" pitchFamily="18" charset="0"/>
+                </a:rPr>
+                <a:t>, </a:t>
+              </a:r>
+              <a:r>
+                <a:rPr kumimoji="0" lang="en-US" altLang="en-US" sz="1600" b="0" i="1" u="none" strike="noStrike" cap="none" normalizeH="0" baseline="0" dirty="0">
+                  <a:ln>
+                    <a:noFill/>
+                  </a:ln>
+                  <a:solidFill>
+                    <a:schemeClr val="tx1"/>
+                  </a:solidFill>
+                  <a:effectLst/>
+                  <a:latin typeface="Times New Roman" panose="02020603050405020304" pitchFamily="18" charset="0"/>
+                  <a:cs typeface="Times New Roman" panose="02020603050405020304" pitchFamily="18" charset="0"/>
+                </a:rPr>
+                <a:t>95% CI (Dice) = 91.24–91.87</a:t>
+              </a:r>
+              <a:r>
+                <a:rPr kumimoji="0" lang="en-US" altLang="en-US" sz="1600" b="0" i="0" u="none" strike="noStrike" cap="none" normalizeH="0" baseline="0" dirty="0">
+                  <a:ln>
+                    <a:noFill/>
+                  </a:ln>
+                  <a:solidFill>
+                    <a:schemeClr val="tx1"/>
+                  </a:solidFill>
+                  <a:effectLst/>
+                  <a:latin typeface="Times New Roman" panose="02020603050405020304" pitchFamily="18" charset="0"/>
+                  <a:cs typeface="Times New Roman" panose="02020603050405020304" pitchFamily="18" charset="0"/>
+                </a:rPr>
+                <a:t>.</a:t>
+              </a:r>
+            </a:p>
+          </p:txBody>
+        </p:sp>
+        <p:sp>
+          <p:nvSpPr>
+            <p:cNvPr id="1198" name="Rectangle: Rounded Corners 1197">
+              <a:extLst>
+                <a:ext uri="{FF2B5EF4-FFF2-40B4-BE49-F238E27FC236}">
+                  <a16:creationId xmlns:a16="http://schemas.microsoft.com/office/drawing/2014/main" id="{0EF76804-C1D2-FCB9-E3E0-F9ACE6CC27D4}"/>
+                </a:ext>
+              </a:extLst>
+            </p:cNvPr>
+            <p:cNvSpPr/>
+            <p:nvPr/>
+          </p:nvSpPr>
+          <p:spPr>
+            <a:xfrm>
+              <a:off x="9370297" y="9768153"/>
+              <a:ext cx="4397737" cy="2178088"/>
+            </a:xfrm>
+            <a:prstGeom prst="roundRect">
+              <a:avLst>
+                <a:gd name="adj" fmla="val 8151"/>
+              </a:avLst>
+            </a:prstGeom>
+            <a:solidFill>
+              <a:srgbClr val="E8EEF2"/>
+            </a:solidFill>
+            <a:ln>
+              <a:solidFill>
+                <a:srgbClr val="D8BEEC"/>
+              </a:solidFill>
+            </a:ln>
+          </p:spPr>
+          <p:style>
+            <a:lnRef idx="2">
+              <a:schemeClr val="accent1">
+                <a:shade val="15000"/>
+              </a:schemeClr>
+            </a:lnRef>
+            <a:fillRef idx="1">
+              <a:schemeClr val="accent1"/>
+            </a:fillRef>
+            <a:effectRef idx="0">
+              <a:schemeClr val="accent1"/>
+            </a:effectRef>
+            <a:fontRef idx="minor">
+              <a:schemeClr val="lt1"/>
+            </a:fontRef>
+          </p:style>
+          <p:txBody>
+            <a:bodyPr rtlCol="0" anchor="ctr"/>
+            <a:lstStyle/>
+            <a:p>
+              <a:pPr algn="ctr"/>
+              <a:endParaRPr lang="en-US"/>
+            </a:p>
+          </p:txBody>
+        </p:sp>
+        <p:sp>
+          <p:nvSpPr>
+            <p:cNvPr id="1199" name="TextBox 1198">
+              <a:extLst>
+                <a:ext uri="{FF2B5EF4-FFF2-40B4-BE49-F238E27FC236}">
+                  <a16:creationId xmlns:a16="http://schemas.microsoft.com/office/drawing/2014/main" id="{3E6AF841-6F7C-E615-E8C5-E5CC19794320}"/>
+                </a:ext>
+              </a:extLst>
+            </p:cNvPr>
+            <p:cNvSpPr txBox="1"/>
+            <p:nvPr/>
+          </p:nvSpPr>
+          <p:spPr>
+            <a:xfrm>
+              <a:off x="9309725" y="9439903"/>
+              <a:ext cx="2541080" cy="338554"/>
+            </a:xfrm>
+            <a:prstGeom prst="rect">
+              <a:avLst/>
+            </a:prstGeom>
+            <a:noFill/>
+          </p:spPr>
+          <p:txBody>
+            <a:bodyPr wrap="none" rtlCol="0">
+              <a:spAutoFit/>
+            </a:bodyPr>
+            <a:lstStyle/>
+            <a:p>
+              <a:pPr algn="ctr"/>
+              <a:r>
+                <a:rPr lang="en-US" sz="1600" dirty="0">
+                  <a:latin typeface="Times New Roman" panose="02020603050405020304" pitchFamily="18" charset="0"/>
+                  <a:cs typeface="Times New Roman" panose="02020603050405020304" pitchFamily="18" charset="0"/>
+                </a:rPr>
+                <a:t>Classification Model Result:</a:t>
+              </a:r>
+            </a:p>
+          </p:txBody>
+        </p:sp>
+        <p:sp>
+          <p:nvSpPr>
+            <p:cNvPr id="1200" name="Rectangle 8">
+              <a:extLst>
+                <a:ext uri="{FF2B5EF4-FFF2-40B4-BE49-F238E27FC236}">
+                  <a16:creationId xmlns:a16="http://schemas.microsoft.com/office/drawing/2014/main" id="{D1442609-FD19-78BF-94EA-90092B235AF6}"/>
+                </a:ext>
+              </a:extLst>
+            </p:cNvPr>
+            <p:cNvSpPr>
+              <a:spLocks noChangeArrowheads="1"/>
+            </p:cNvSpPr>
+            <p:nvPr/>
+          </p:nvSpPr>
+          <p:spPr bwMode="auto">
+            <a:xfrm>
+              <a:off x="9309725" y="9841545"/>
+              <a:ext cx="4457509" cy="1672253"/>
+            </a:xfrm>
+            <a:prstGeom prst="rect">
+              <a:avLst/>
+            </a:prstGeom>
+            <a:noFill/>
+            <a:ln>
+              <a:noFill/>
+            </a:ln>
+            <a:effectLst/>
+            <a:extLst>
+              <a:ext uri="{909E8E84-426E-40DD-AFC4-6F175D3DCCD1}">
+                <a14:hiddenFill xmlns:a14="http://schemas.microsoft.com/office/drawing/2010/main">
+                  <a:solidFill>
+                    <a:schemeClr val="accent1"/>
+                  </a:solidFill>
+                </a14:hiddenFill>
+              </a:ext>
+              <a:ext uri="{91240B29-F687-4F45-9708-019B960494DF}">
+                <a14:hiddenLine xmlns:a14="http://schemas.microsoft.com/office/drawing/2010/main" w="9525">
+                  <a:solidFill>
+                    <a:schemeClr val="tx1"/>
+                  </a:solidFill>
+                  <a:miter lim="800000"/>
+                  <a:headEnd/>
+                  <a:tailEnd/>
+                </a14:hiddenLine>
+              </a:ext>
+              <a:ext uri="{AF507438-7753-43E0-B8FC-AC1667EBCBE1}">
+                <a14:hiddenEffects xmlns:a14="http://schemas.microsoft.com/office/drawing/2010/main">
+                  <a:effectLst>
+                    <a:outerShdw dist="35921" dir="2700000" algn="ctr" rotWithShape="0">
+                      <a:schemeClr val="bg2"/>
+                    </a:outerShdw>
+                  </a:effectLst>
+                </a14:hiddenEffects>
+              </a:ext>
+            </a:extLst>
+          </p:spPr>
+          <p:txBody>
+            <a:bodyPr vert="horz" wrap="square" lIns="91440" tIns="45720" rIns="91440" bIns="45720" numCol="1" anchor="ctr" anchorCtr="0" compatLnSpc="1">
+              <a:prstTxWarp prst="textNoShape">
+                <a:avLst/>
+              </a:prstTxWarp>
+              <a:spAutoFit/>
+            </a:bodyPr>
+            <a:lstStyle/>
+            <a:p>
+              <a:pPr marL="285750" marR="0" lvl="0" indent="-285750" algn="just" defTabSz="914400" rtl="0" eaLnBrk="0" fontAlgn="base" latinLnBrk="0" hangingPunct="0">
+                <a:lnSpc>
+                  <a:spcPct val="100000"/>
+                </a:lnSpc>
+                <a:spcBef>
+                  <a:spcPct val="0"/>
+                </a:spcBef>
+                <a:spcAft>
+                  <a:spcPts val="800"/>
+                </a:spcAft>
+                <a:buClrTx/>
+                <a:buSzTx/>
+                <a:buFont typeface="Arial" panose="020B0604020202020204" pitchFamily="34" charset="0"/>
+                <a:buChar char="•"/>
+                <a:tabLst/>
+              </a:pPr>
+              <a:r>
+                <a:rPr kumimoji="0" lang="en-US" altLang="en-US" sz="1600" b="1" i="0" u="none" strike="noStrike" cap="none" normalizeH="0" baseline="0" dirty="0">
+                  <a:ln>
+                    <a:noFill/>
+                  </a:ln>
+                  <a:solidFill>
+                    <a:schemeClr val="tx1"/>
+                  </a:solidFill>
+                  <a:effectLst/>
+                  <a:latin typeface="Times New Roman" panose="02020603050405020304" pitchFamily="18" charset="0"/>
+                  <a:cs typeface="Times New Roman" panose="02020603050405020304" pitchFamily="18" charset="0"/>
+                </a:rPr>
+                <a:t>HAM10000 (10% hold-out test set): </a:t>
+              </a:r>
+              <a:r>
+                <a:rPr kumimoji="0" lang="en-US" altLang="en-US" sz="1600" b="0" i="0" u="none" strike="noStrike" cap="none" normalizeH="0" baseline="0" dirty="0">
+                  <a:ln>
+                    <a:noFill/>
+                  </a:ln>
+                  <a:solidFill>
+                    <a:schemeClr val="tx1"/>
+                  </a:solidFill>
+                  <a:effectLst/>
+                  <a:latin typeface="Times New Roman" panose="02020603050405020304" pitchFamily="18" charset="0"/>
+                  <a:cs typeface="Times New Roman" panose="02020603050405020304" pitchFamily="18" charset="0"/>
+                </a:rPr>
+                <a:t>Accuracy = 98.15%, F1-score = 98.15%, AUC = 99.91%, 95% CI (Accuracy) = 97.79–98.55%.</a:t>
+              </a:r>
+            </a:p>
+            <a:p>
+              <a:pPr marL="285750" marR="0" lvl="0" indent="-285750" algn="just" defTabSz="914400" rtl="0" eaLnBrk="0" fontAlgn="base" latinLnBrk="0" hangingPunct="0">
+                <a:lnSpc>
+                  <a:spcPct val="100000"/>
+                </a:lnSpc>
+                <a:spcBef>
+                  <a:spcPct val="0"/>
+                </a:spcBef>
+                <a:spcAft>
+                  <a:spcPts val="800"/>
+                </a:spcAft>
+                <a:buClrTx/>
+                <a:buSzTx/>
+                <a:buFont typeface="Arial" panose="020B0604020202020204" pitchFamily="34" charset="0"/>
+                <a:buChar char="•"/>
+                <a:tabLst/>
+              </a:pPr>
+              <a:r>
+                <a:rPr kumimoji="0" lang="en-US" altLang="en-US" sz="1600" b="1" i="0" u="none" strike="noStrike" cap="none" normalizeH="0" baseline="0" dirty="0">
+                  <a:ln>
+                    <a:noFill/>
+                  </a:ln>
+                  <a:solidFill>
+                    <a:schemeClr val="tx1"/>
+                  </a:solidFill>
+                  <a:effectLst/>
+                  <a:latin typeface="Times New Roman" panose="02020603050405020304" pitchFamily="18" charset="0"/>
+                  <a:cs typeface="Times New Roman" panose="02020603050405020304" pitchFamily="18" charset="0"/>
+                </a:rPr>
+                <a:t>MILK10K (10% hold-out test set): </a:t>
+              </a:r>
+              <a:r>
+                <a:rPr kumimoji="0" lang="en-US" altLang="en-US" sz="1600" b="0" i="0" u="none" strike="noStrike" cap="none" normalizeH="0" baseline="0" dirty="0">
+                  <a:ln>
+                    <a:noFill/>
+                  </a:ln>
+                  <a:solidFill>
+                    <a:schemeClr val="tx1"/>
+                  </a:solidFill>
+                  <a:effectLst/>
+                  <a:latin typeface="Times New Roman" panose="02020603050405020304" pitchFamily="18" charset="0"/>
+                  <a:cs typeface="Times New Roman" panose="02020603050405020304" pitchFamily="18" charset="0"/>
+                </a:rPr>
+                <a:t>Accuracy = 87.03%, F1-score = 86.82%, AUC = 97.78%, 95% CI (Accuracy) = 85.40–88.60%.</a:t>
+              </a:r>
+            </a:p>
+          </p:txBody>
+        </p:sp>
+        <p:sp>
+          <p:nvSpPr>
+            <p:cNvPr id="1203" name="TextBox 1202">
+              <a:extLst>
+                <a:ext uri="{FF2B5EF4-FFF2-40B4-BE49-F238E27FC236}">
+                  <a16:creationId xmlns:a16="http://schemas.microsoft.com/office/drawing/2014/main" id="{CCD4AEDE-94F1-85B8-EBB2-FDD1AB4FA160}"/>
+                </a:ext>
+              </a:extLst>
+            </p:cNvPr>
+            <p:cNvSpPr txBox="1"/>
+            <p:nvPr/>
+          </p:nvSpPr>
+          <p:spPr>
+            <a:xfrm>
+              <a:off x="9487753" y="11451940"/>
+              <a:ext cx="4279482" cy="523220"/>
+            </a:xfrm>
+            <a:prstGeom prst="rect">
+              <a:avLst/>
+            </a:prstGeom>
+            <a:noFill/>
+          </p:spPr>
+          <p:txBody>
+            <a:bodyPr wrap="square">
+              <a:spAutoFit/>
+            </a:bodyPr>
+            <a:lstStyle/>
+            <a:p>
+              <a:pPr algn="ctr">
+                <a:buNone/>
+              </a:pPr>
+              <a:r>
+                <a:rPr lang="en-US" sz="1400" i="1" dirty="0">
+                  <a:latin typeface="Times New Roman" panose="02020603050405020304" pitchFamily="18" charset="0"/>
+                  <a:cs typeface="Times New Roman" panose="02020603050405020304" pitchFamily="18" charset="0"/>
+                </a:rPr>
+                <a:t>(Note: Classification datasets were first segmented using the proposed segmentation model.)</a:t>
+              </a:r>
+              <a:endParaRPr kumimoji="0" lang="en-US" altLang="en-US" sz="1400" b="1" i="0" u="none" strike="noStrike" cap="none" normalizeH="0" baseline="0" dirty="0">
+                <a:ln>
+                  <a:noFill/>
+                </a:ln>
+                <a:solidFill>
+                  <a:schemeClr val="tx1"/>
+                </a:solidFill>
+                <a:effectLst/>
+                <a:latin typeface="Times New Roman" panose="02020603050405020304" pitchFamily="18" charset="0"/>
+                <a:cs typeface="Times New Roman" panose="02020603050405020304" pitchFamily="18" charset="0"/>
+              </a:endParaRPr>
+            </a:p>
+          </p:txBody>
+        </p:sp>
+      </p:grpSp>
+    </p:spTree>
+    <p:extLst>
+      <p:ext uri="{BB962C8B-B14F-4D97-AF65-F5344CB8AC3E}">
+        <p14:creationId xmlns:p14="http://schemas.microsoft.com/office/powerpoint/2010/main" val="2583167346"/>
+      </p:ext>
+    </p:extLst>
+  </p:cSld>
+  <p:clrMapOvr>
+    <a:masterClrMapping/>
+  </p:clrMapOvr>
+</p:sld>
+</file>
+
 <file path=ppt/theme/theme1.xml><?xml version="1.0" encoding="utf-8"?>
 <a:theme xmlns:a="http://schemas.openxmlformats.org/drawingml/2006/main" name="Office Theme">
   <a:themeElements>

</xml_diff>